<commit_message>
Add 10 advanced/enterprise sections (Security, Running 24/7, Interfaces, Chat, Capabilities, Configuration, Multi-instance, Snapshot, Apps, Troubleshooting) for full docs/crew coverage; pptx 29->40 slides
</commit_message>
<xml_diff>
--- a/kiro-crew-training.pptx
+++ b/kiro-crew-training.pptx
@@ -34,6 +34,17 @@
     <p:sldId id="282" r:id="rId33"/>
     <p:sldId id="283" r:id="rId34"/>
     <p:sldId id="284" r:id="rId35"/>
+    <p:sldId id="285" r:id="rId36"/>
+    <p:sldId id="286" r:id="rId37"/>
+    <p:sldId id="287" r:id="rId38"/>
+    <p:sldId id="288" r:id="rId39"/>
+    <p:sldId id="289" r:id="rId40"/>
+    <p:sldId id="290" r:id="rId41"/>
+    <p:sldId id="291" r:id="rId42"/>
+    <p:sldId id="292" r:id="rId43"/>
+    <p:sldId id="293" r:id="rId44"/>
+    <p:sldId id="294" r:id="rId45"/>
+    <p:sldId id="295" r:id="rId46"/>
   </p:sldIdLst>
   <p:sldSz cx="9144000" cy="6858000" type="screen4x3"/>
   <p:notesSz cx="6858000" cy="9144000"/>
@@ -5815,7 +5826,7 @@
               </a:defRPr>
             </a:pPr>
             <a:r>
-              <a:t>Part 4: Use Cases</a:t>
+              <a:t>Advanced &amp; Enterprise Topics</a:t>
             </a:r>
           </a:p>
         </p:txBody>
@@ -5850,7 +5861,7 @@
               </a:defRPr>
             </a:pPr>
             <a:r>
-              <a:t>Enterprise integration examples</a:t>
+              <a:t>Full coverage of docs/crew/</a:t>
             </a:r>
           </a:p>
         </p:txBody>
@@ -5911,7 +5922,7 @@
               </a:defRPr>
             </a:pPr>
             <a:r>
-              <a:t>Example: 24/7 PR Monitoring</a:t>
+              <a:t>Security: 8-Layer Defense-in-Depth</a:t>
             </a:r>
           </a:p>
         </p:txBody>
@@ -5941,12 +5952,12 @@
             <a:pPr>
               <a:defRPr sz="1100" b="1">
                 <a:solidFill>
-                  <a:srgbClr val="F59E0B"/>
-                </a:solidFill>
-              </a:defRPr>
-            </a:pPr>
-            <a:r>
-              <a:t>⚠ To Be Verified</a:t>
+                  <a:srgbClr val="10B981"/>
+                </a:solidFill>
+              </a:defRPr>
+            </a:pPr>
+            <a:r>
+              <a:t>✓ Verified</a:t>
             </a:r>
           </a:p>
         </p:txBody>
@@ -5984,133 +5995,124 @@
               </a:defRPr>
             </a:pPr>
             <a:r>
-              <a:t>Scenario: Track open PRs and alert on staleness</a:t>
-            </a:r>
-          </a:p>
-          <a:p>
-            <a:pPr>
-              <a:spcBef>
-                <a:spcPts val="800"/>
-              </a:spcBef>
-              <a:defRPr sz="1800">
-                <a:solidFill>
-                  <a:srgbClr val="F1F5F9"/>
-                </a:solidFill>
-              </a:defRPr>
-            </a:pPr>
-          </a:p>
-          <a:p>
-            <a:pPr>
-              <a:spcBef>
-                <a:spcPts val="800"/>
-              </a:spcBef>
-              <a:defRPr sz="1800">
-                <a:solidFill>
-                  <a:srgbClr val="F1F5F9"/>
-                </a:solidFill>
-              </a:defRPr>
-            </a:pPr>
-            <a:r>
-              <a:t>Implementation:</a:t>
-            </a:r>
-          </a:p>
-          <a:p>
-            <a:pPr>
-              <a:spcBef>
-                <a:spcPts val="800"/>
-              </a:spcBef>
-              <a:defRPr sz="1800">
-                <a:solidFill>
-                  <a:srgbClr val="F1F5F9"/>
-                </a:solidFill>
-              </a:defRPr>
-            </a:pPr>
-            <a:r>
-              <a:t>• Heartbeat watches open PRs</a:t>
-            </a:r>
-          </a:p>
-          <a:p>
-            <a:pPr>
-              <a:spcBef>
-                <a:spcPts val="800"/>
-              </a:spcBef>
-              <a:defRPr sz="1800">
-                <a:solidFill>
-                  <a:srgbClr val="F1F5F9"/>
-                </a:solidFill>
-              </a:defRPr>
-            </a:pPr>
-            <a:r>
-              <a:t>• Alerts when stale (&gt;4 hours no review)</a:t>
-            </a:r>
-          </a:p>
-          <a:p>
-            <a:pPr>
-              <a:spcBef>
-                <a:spcPts val="800"/>
-              </a:spcBef>
-              <a:defRPr sz="1800">
-                <a:solidFill>
-                  <a:srgbClr val="F1F5F9"/>
-                </a:solidFill>
-              </a:defRPr>
-            </a:pPr>
-            <a:r>
-              <a:t>• Auto-pings reviewers via Slack</a:t>
-            </a:r>
-          </a:p>
-          <a:p>
-            <a:pPr>
-              <a:spcBef>
-                <a:spcPts val="800"/>
-              </a:spcBef>
-              <a:defRPr sz="1800">
-                <a:solidFill>
-                  <a:srgbClr val="F1F5F9"/>
-                </a:solidFill>
-              </a:defRPr>
-            </a:pPr>
-          </a:p>
-          <a:p>
-            <a:pPr>
-              <a:spcBef>
-                <a:spcPts val="800"/>
-              </a:spcBef>
-              <a:defRPr sz="1800">
-                <a:solidFill>
-                  <a:srgbClr val="F1F5F9"/>
-                </a:solidFill>
-              </a:defRPr>
-            </a:pPr>
-            <a:r>
-              <a:t>Uses: Heartbeats + Slack integration</a:t>
-            </a:r>
-          </a:p>
-          <a:p>
-            <a:pPr>
-              <a:spcBef>
-                <a:spcPts val="800"/>
-              </a:spcBef>
-              <a:defRPr sz="1800">
-                <a:solidFill>
-                  <a:srgbClr val="F1F5F9"/>
-                </a:solidFill>
-              </a:defRPr>
-            </a:pPr>
-          </a:p>
-          <a:p>
-            <a:pPr>
-              <a:spcBef>
-                <a:spcPts val="800"/>
-              </a:spcBef>
-              <a:defRPr sz="1800">
-                <a:solidFill>
-                  <a:srgbClr val="F1F5F9"/>
-                </a:solidFill>
-              </a:defRPr>
-            </a:pPr>
-            <a:r>
-              <a:t>Note: Example scenario based on documented capabilities</a:t>
+              <a:t>Every tool call passes independent layers (runtime-enforced):</a:t>
+            </a:r>
+          </a:p>
+          <a:p>
+            <a:pPr>
+              <a:spcBef>
+                <a:spcPts val="800"/>
+              </a:spcBef>
+              <a:defRPr sz="1800">
+                <a:solidFill>
+                  <a:srgbClr val="F1F5F9"/>
+                </a:solidFill>
+              </a:defRPr>
+            </a:pPr>
+            <a:r>
+              <a:t>1 Owner lock  2 Denied commands (137)  3 Governance ceiling</a:t>
+            </a:r>
+          </a:p>
+          <a:p>
+            <a:pPr>
+              <a:spcBef>
+                <a:spcPts val="800"/>
+              </a:spcBef>
+              <a:defRPr sz="1800">
+                <a:solidFill>
+                  <a:srgbClr val="F1F5F9"/>
+                </a:solidFill>
+              </a:defRPr>
+            </a:pPr>
+            <a:r>
+              <a:t>4 Sensitive-path block  5 Tool approval  6 Input validation</a:t>
+            </a:r>
+          </a:p>
+          <a:p>
+            <a:pPr>
+              <a:spcBef>
+                <a:spcPts val="800"/>
+              </a:spcBef>
+              <a:defRPr sz="1800">
+                <a:solidFill>
+                  <a:srgbClr val="F1F5F9"/>
+                </a:solidFill>
+              </a:defRPr>
+            </a:pPr>
+            <a:r>
+              <a:t>7 OS sandbox  8 Output redaction  (+ SEL audit, cross-cutting)</a:t>
+            </a:r>
+          </a:p>
+          <a:p>
+            <a:pPr>
+              <a:spcBef>
+                <a:spcPts val="800"/>
+              </a:spcBef>
+              <a:defRPr sz="1800">
+                <a:solidFill>
+                  <a:srgbClr val="F1F5F9"/>
+                </a:solidFill>
+              </a:defRPr>
+            </a:pPr>
+          </a:p>
+          <a:p>
+            <a:pPr>
+              <a:spcBef>
+                <a:spcPts val="800"/>
+              </a:spcBef>
+              <a:defRPr sz="1800">
+                <a:solidFill>
+                  <a:srgbClr val="F1F5F9"/>
+                </a:solidFill>
+              </a:defRPr>
+            </a:pPr>
+            <a:r>
+              <a:t>Sandbox: auto (default) / strict / off; no OS layer on Windows</a:t>
+            </a:r>
+          </a:p>
+          <a:p>
+            <a:pPr>
+              <a:spcBef>
+                <a:spcPts val="800"/>
+              </a:spcBef>
+              <a:defRPr sz="1800">
+                <a:solidFill>
+                  <a:srgbClr val="F1F5F9"/>
+                </a:solidFill>
+              </a:defRPr>
+            </a:pPr>
+            <a:r>
+              <a:t>Approval: Interactive / Trust command / Trust tool / Autopilot</a:t>
+            </a:r>
+          </a:p>
+          <a:p>
+            <a:pPr>
+              <a:spcBef>
+                <a:spcPts val="800"/>
+              </a:spcBef>
+              <a:defRPr sz="1800">
+                <a:solidFill>
+                  <a:srgbClr val="F1F5F9"/>
+                </a:solidFill>
+              </a:defRPr>
+            </a:pPr>
+            <a:r>
+              <a:t>Denied cmds enforced at Crew's gate, not agent config</a:t>
+            </a:r>
+          </a:p>
+          <a:p>
+            <a:pPr>
+              <a:spcBef>
+                <a:spcPts val="800"/>
+              </a:spcBef>
+              <a:defRPr sz="1800">
+                <a:solidFill>
+                  <a:srgbClr val="F1F5F9"/>
+                </a:solidFill>
+              </a:defRPr>
+            </a:pPr>
+            <a:r>
+              <a:t>kirocrew policy show|validate|explain; security events|audit|verify</a:t>
             </a:r>
           </a:p>
         </p:txBody>
@@ -6171,7 +6173,7 @@
               </a:defRPr>
             </a:pPr>
             <a:r>
-              <a:t>Example: Nightly Security Audit</a:t>
+              <a:t>Running 24/7</a:t>
             </a:r>
           </a:p>
         </p:txBody>
@@ -6201,12 +6203,12 @@
             <a:pPr>
               <a:defRPr sz="1100" b="1">
                 <a:solidFill>
-                  <a:srgbClr val="F59E0B"/>
-                </a:solidFill>
-              </a:defRPr>
-            </a:pPr>
-            <a:r>
-              <a:t>⚠ To Be Verified</a:t>
+                  <a:srgbClr val="10B981"/>
+                </a:solidFill>
+              </a:defRPr>
+            </a:pPr>
+            <a:r>
+              <a:t>✓ Verified</a:t>
             </a:r>
           </a:p>
         </p:txBody>
@@ -6244,136 +6246,112 @@
               </a:defRPr>
             </a:pPr>
             <a:r>
-              <a:t>Scenario: Automated security scanning</a:t>
-            </a:r>
-          </a:p>
-          <a:p>
-            <a:pPr>
-              <a:spcBef>
-                <a:spcPts val="800"/>
-              </a:spcBef>
-              <a:defRPr sz="1800">
-                <a:solidFill>
-                  <a:srgbClr val="F1F5F9"/>
-                </a:solidFill>
-              </a:defRPr>
-            </a:pPr>
-          </a:p>
-          <a:p>
-            <a:pPr>
-              <a:spcBef>
-                <a:spcPts val="800"/>
-              </a:spcBef>
-              <a:defRPr sz="1800">
-                <a:solidFill>
-                  <a:srgbClr val="F1F5F9"/>
-                </a:solidFill>
-              </a:defRPr>
-            </a:pPr>
-            <a:r>
-              <a:t>Implementation:</a:t>
-            </a:r>
-          </a:p>
-          <a:p>
-            <a:pPr>
-              <a:spcBef>
-                <a:spcPts val="800"/>
-              </a:spcBef>
-              <a:defRPr sz="1800">
-                <a:solidFill>
-                  <a:srgbClr val="F1F5F9"/>
-                </a:solidFill>
-              </a:defRPr>
-            </a:pPr>
-            <a:r>
-              <a:t>• Cron job at 2am</a:t>
-            </a:r>
-          </a:p>
-          <a:p>
-            <a:pPr>
-              <a:spcBef>
-                <a:spcPts val="800"/>
-              </a:spcBef>
-              <a:defRPr sz="1800">
-                <a:solidFill>
-                  <a:srgbClr val="F1F5F9"/>
-                </a:solidFill>
-              </a:defRPr>
-            </a:pPr>
-            <a:r>
-              <a:t>• Spawns subagents (one per repo)</a:t>
-            </a:r>
-          </a:p>
-          <a:p>
-            <a:pPr>
-              <a:spcBef>
-                <a:spcPts val="800"/>
-              </a:spcBef>
-              <a:defRPr sz="1800">
-                <a:solidFill>
-                  <a:srgbClr val="F1F5F9"/>
-                </a:solidFill>
-              </a:defRPr>
-            </a:pPr>
-            <a:r>
-              <a:t>• Scans for secrets, vulnerabilities, misconfigurations</a:t>
-            </a:r>
-          </a:p>
-          <a:p>
-            <a:pPr>
-              <a:spcBef>
-                <a:spcPts val="800"/>
-              </a:spcBef>
-              <a:defRPr sz="1800">
-                <a:solidFill>
-                  <a:srgbClr val="F1F5F9"/>
-                </a:solidFill>
-              </a:defRPr>
-            </a:pPr>
-            <a:r>
-              <a:t>• Aggregates findings into report</a:t>
-            </a:r>
-          </a:p>
-          <a:p>
-            <a:pPr>
-              <a:spcBef>
-                <a:spcPts val="800"/>
-              </a:spcBef>
-              <a:defRPr sz="1800">
-                <a:solidFill>
-                  <a:srgbClr val="F1F5F9"/>
-                </a:solidFill>
-              </a:defRPr>
-            </a:pPr>
-            <a:r>
-              <a:t>• Files HIGH/CRITICAL tickets</a:t>
-            </a:r>
-          </a:p>
-          <a:p>
-            <a:pPr>
-              <a:spcBef>
-                <a:spcPts val="800"/>
-              </a:spcBef>
-              <a:defRPr sz="1800">
-                <a:solidFill>
-                  <a:srgbClr val="F1F5F9"/>
-                </a:solidFill>
-              </a:defRPr>
-            </a:pPr>
-          </a:p>
-          <a:p>
-            <a:pPr>
-              <a:spcBef>
-                <a:spcPts val="800"/>
-              </a:spcBef>
-              <a:defRPr sz="1800">
-                <a:solidFill>
-                  <a:srgbClr val="F1F5F9"/>
-                </a:solidFill>
-              </a:defRPr>
-            </a:pPr>
-            <a:r>
-              <a:t>Uses: Cron + Subagents + Task automation</a:t>
+              <a:t>Local service: systemd/launchd; runs as user, sudo once for unit</a:t>
+            </a:r>
+          </a:p>
+          <a:p>
+            <a:pPr>
+              <a:spcBef>
+                <a:spcPts val="800"/>
+              </a:spcBef>
+              <a:defRPr sz="1800">
+                <a:solidFill>
+                  <a:srgbClr val="F1F5F9"/>
+                </a:solidFill>
+              </a:defRPr>
+            </a:pPr>
+            <a:r>
+              <a:t>  kirocrew service install | logs -f | restart</a:t>
+            </a:r>
+          </a:p>
+          <a:p>
+            <a:pPr>
+              <a:spcBef>
+                <a:spcPts val="800"/>
+              </a:spcBef>
+              <a:defRPr sz="1800">
+                <a:solidFill>
+                  <a:srgbClr val="F1F5F9"/>
+                </a:solidFill>
+              </a:defRPr>
+            </a:pPr>
+            <a:r>
+              <a:t>Docker: multi-arch GHCR; kiro-cli login + kirocrew token; SLSA</a:t>
+            </a:r>
+          </a:p>
+          <a:p>
+            <a:pPr>
+              <a:spcBef>
+                <a:spcPts val="800"/>
+              </a:spcBef>
+              <a:defRPr sz="1800">
+                <a:solidFill>
+                  <a:srgbClr val="F1F5F9"/>
+                </a:solidFill>
+              </a:defRPr>
+            </a:pPr>
+            <a:r>
+              <a:t>  docker run -d -p 127.0.0.1:5476:5476 -v kirocrew-home:...</a:t>
+            </a:r>
+          </a:p>
+          <a:p>
+            <a:pPr>
+              <a:spcBef>
+                <a:spcPts val="800"/>
+              </a:spcBef>
+              <a:defRPr sz="1800">
+                <a:solidFill>
+                  <a:srgbClr val="F1F5F9"/>
+                </a:solidFill>
+              </a:defRPr>
+            </a:pPr>
+            <a:r>
+              <a:t>Remote host: modern Linux, ~10GB RAM, Node 20+ (slack-mcp)</a:t>
+            </a:r>
+          </a:p>
+          <a:p>
+            <a:pPr>
+              <a:spcBef>
+                <a:spcPts val="800"/>
+              </a:spcBef>
+              <a:defRPr sz="1800">
+                <a:solidFill>
+                  <a:srgbClr val="F1F5F9"/>
+                </a:solidFill>
+              </a:defRPr>
+            </a:pPr>
+            <a:r>
+              <a:t>  ssh -L 5476:localhost:5476 user@host</a:t>
+            </a:r>
+          </a:p>
+          <a:p>
+            <a:pPr>
+              <a:spcBef>
+                <a:spcPts val="800"/>
+              </a:spcBef>
+              <a:defRPr sz="1800">
+                <a:solidFill>
+                  <a:srgbClr val="F1F5F9"/>
+                </a:solidFill>
+              </a:defRPr>
+            </a:pPr>
+            <a:r>
+              <a:t>Sync state: memory + SQLite incl WAL; NOT .env/.local_secret</a:t>
+            </a:r>
+          </a:p>
+          <a:p>
+            <a:pPr>
+              <a:spcBef>
+                <a:spcPts val="800"/>
+              </a:spcBef>
+              <a:defRPr sz="1800">
+                <a:solidFill>
+                  <a:srgbClr val="F1F5F9"/>
+                </a:solidFill>
+              </a:defRPr>
+            </a:pPr>
+            <a:r>
+              <a:t>Mobile: Cloudflare/ngrok/Tailscale + dashboard.url; token 1h/20h</a:t>
             </a:r>
           </a:p>
         </p:txBody>
@@ -6434,7 +6412,7 @@
               </a:defRPr>
             </a:pPr>
             <a:r>
-              <a:t>Example: Incident Response</a:t>
+              <a:t>Interfaces: One Gateway, Many Surfaces</a:t>
             </a:r>
           </a:p>
         </p:txBody>
@@ -6464,12 +6442,12 @@
             <a:pPr>
               <a:defRPr sz="1100" b="1">
                 <a:solidFill>
-                  <a:srgbClr val="F59E0B"/>
-                </a:solidFill>
-              </a:defRPr>
-            </a:pPr>
-            <a:r>
-              <a:t>⚠ To Be Verified</a:t>
+                  <a:srgbClr val="10B981"/>
+                </a:solidFill>
+              </a:defRPr>
+            </a:pPr>
+            <a:r>
+              <a:t>✓ Verified</a:t>
             </a:r>
           </a:p>
         </p:txBody>
@@ -6507,151 +6485,109 @@
               </a:defRPr>
             </a:pPr>
             <a:r>
-              <a:t>Scenario: Automated triage and RCA</a:t>
-            </a:r>
-          </a:p>
-          <a:p>
-            <a:pPr>
-              <a:spcBef>
-                <a:spcPts val="800"/>
-              </a:spcBef>
-              <a:defRPr sz="1800">
-                <a:solidFill>
-                  <a:srgbClr val="F1F5F9"/>
-                </a:solidFill>
-              </a:defRPr>
-            </a:pPr>
-          </a:p>
-          <a:p>
-            <a:pPr>
-              <a:spcBef>
-                <a:spcPts val="800"/>
-              </a:spcBef>
-              <a:defRPr sz="1800">
-                <a:solidFill>
-                  <a:srgbClr val="F1F5F9"/>
-                </a:solidFill>
-              </a:defRPr>
-            </a:pPr>
-            <a:r>
-              <a:t>Implementation:</a:t>
-            </a:r>
-          </a:p>
-          <a:p>
-            <a:pPr>
-              <a:spcBef>
-                <a:spcPts val="800"/>
-              </a:spcBef>
-              <a:defRPr sz="1800">
-                <a:solidFill>
-                  <a:srgbClr val="F1F5F9"/>
-                </a:solidFill>
-              </a:defRPr>
-            </a:pPr>
-            <a:r>
-              <a:t>• Webhook from PagerDuty</a:t>
-            </a:r>
-          </a:p>
-          <a:p>
-            <a:pPr>
-              <a:spcBef>
-                <a:spcPts val="800"/>
-              </a:spcBef>
-              <a:defRPr sz="1800">
-                <a:solidFill>
-                  <a:srgbClr val="F1F5F9"/>
-                </a:solidFill>
-              </a:defRPr>
-            </a:pPr>
-            <a:r>
-              <a:t>• Crew triages alert</a:t>
-            </a:r>
-          </a:p>
-          <a:p>
-            <a:pPr>
-              <a:spcBef>
-                <a:spcPts val="800"/>
-              </a:spcBef>
-              <a:defRPr sz="1800">
-                <a:solidFill>
-                  <a:srgbClr val="F1F5F9"/>
-                </a:solidFill>
-              </a:defRPr>
-            </a:pPr>
-            <a:r>
-              <a:t>• Checks logs, metrics, recent deploys</a:t>
-            </a:r>
-          </a:p>
-          <a:p>
-            <a:pPr>
-              <a:spcBef>
-                <a:spcPts val="800"/>
-              </a:spcBef>
-              <a:defRPr sz="1800">
-                <a:solidFill>
-                  <a:srgbClr val="F1F5F9"/>
-                </a:solidFill>
-              </a:defRPr>
-            </a:pPr>
-            <a:r>
-              <a:t>• Applies known fixes (from memory/lessons)</a:t>
-            </a:r>
-          </a:p>
-          <a:p>
-            <a:pPr>
-              <a:spcBef>
-                <a:spcPts val="800"/>
-              </a:spcBef>
-              <a:defRPr sz="1800">
-                <a:solidFill>
-                  <a:srgbClr val="F1F5F9"/>
-                </a:solidFill>
-              </a:defRPr>
-            </a:pPr>
-            <a:r>
-              <a:t>• Escalates if novel</a:t>
-            </a:r>
-          </a:p>
-          <a:p>
-            <a:pPr>
-              <a:spcBef>
-                <a:spcPts val="800"/>
-              </a:spcBef>
-              <a:defRPr sz="1800">
-                <a:solidFill>
-                  <a:srgbClr val="F1F5F9"/>
-                </a:solidFill>
-              </a:defRPr>
-            </a:pPr>
-            <a:r>
-              <a:t>• Posts RCA when resolved</a:t>
-            </a:r>
-          </a:p>
-          <a:p>
-            <a:pPr>
-              <a:spcBef>
-                <a:spcPts val="800"/>
-              </a:spcBef>
-              <a:defRPr sz="1800">
-                <a:solidFill>
-                  <a:srgbClr val="F1F5F9"/>
-                </a:solidFill>
-              </a:defRPr>
-            </a:pPr>
-          </a:p>
-          <a:p>
-            <a:pPr>
-              <a:spcBef>
-                <a:spcPts val="800"/>
-              </a:spcBef>
-              <a:defRPr sz="1800">
-                <a:solidFill>
-                  <a:srgbClr val="F1F5F9"/>
-                </a:solidFill>
-              </a:defRPr>
-            </a:pPr>
-            <a:r>
-              <a:t>Uses: Webhooks + Memory + Knowledge</a:t>
+              <a:t>Mac app / web dashboard / CLI + Slack/Discord/Telegram/</a:t>
+            </a:r>
+          </a:p>
+          <a:p>
+            <a:pPr>
+              <a:spcBef>
+                <a:spcPts val="800"/>
+              </a:spcBef>
+              <a:defRPr sz="1800">
+                <a:solidFill>
+                  <a:srgbClr val="F1F5F9"/>
+                </a:solidFill>
+              </a:defRPr>
+            </a:pPr>
+            <a:r>
+              <a:t>Teams/Webex/WeCom/WeChat channels</a:t>
+            </a:r>
+          </a:p>
+          <a:p>
+            <a:pPr>
+              <a:spcBef>
+                <a:spcPts val="800"/>
+              </a:spcBef>
+              <a:defRPr sz="1800">
+                <a:solidFill>
+                  <a:srgbClr val="F1F5F9"/>
+                </a:solidFill>
+              </a:defRPr>
+            </a:pPr>
+            <a:r>
+              <a:t>Independent sessions, SHARED memory/skills/lessons/crons</a:t>
+            </a:r>
+          </a:p>
+          <a:p>
+            <a:pPr>
+              <a:spcBef>
+                <a:spcPts val="800"/>
+              </a:spcBef>
+              <a:defRPr sz="1800">
+                <a:solidFill>
+                  <a:srgbClr val="F1F5F9"/>
+                </a:solidFill>
+              </a:defRPr>
+            </a:pPr>
+            <a:r>
+              <a:t>Channels connect outbound - no need to expose dashboard port</a:t>
+            </a:r>
+          </a:p>
+          <a:p>
+            <a:pPr>
+              <a:spcBef>
+                <a:spcPts val="800"/>
+              </a:spcBef>
+              <a:defRPr sz="1800">
+                <a:solidFill>
+                  <a:srgbClr val="F1F5F9"/>
+                </a:solidFill>
+              </a:defRPr>
+            </a:pPr>
+          </a:p>
+          <a:p>
+            <a:pPr>
+              <a:spcBef>
+                <a:spcPts val="800"/>
+              </a:spcBef>
+              <a:defRPr sz="1800">
+                <a:solidFill>
+                  <a:srgbClr val="F1F5F9"/>
+                </a:solidFill>
+              </a:defRPr>
+            </a:pPr>
+            <a:r>
+              <a:t>Dashboard = React SPA localhost:5476 (primary interface)</a:t>
+            </a:r>
+          </a:p>
+          <a:p>
+            <a:pPr>
+              <a:spcBef>
+                <a:spcPts val="800"/>
+              </a:spcBef>
+              <a:defRPr sz="1800">
+                <a:solidFill>
+                  <a:srgbClr val="F1F5F9"/>
+                </a:solidFill>
+              </a:defRPr>
+            </a:pPr>
+            <a:r>
+              <a:t>Cross-surface: dashboard&lt;-&gt;Slack sync, resume sessions</a:t>
+            </a:r>
+          </a:p>
+          <a:p>
+            <a:pPr>
+              <a:spcBef>
+                <a:spcPts val="800"/>
+              </a:spcBef>
+              <a:defRPr sz="1800">
+                <a:solidFill>
+                  <a:srgbClr val="F1F5F9"/>
+                </a:solidFill>
+              </a:defRPr>
+            </a:pPr>
+            <a:r>
+              <a:t>5476 loopback-only default; reverse proxy+TLS or SSH tunnel</a:t>
             </a:r>
           </a:p>
         </p:txBody>
@@ -6712,7 +6648,7 @@
               </a:defRPr>
             </a:pPr>
             <a:r>
-              <a:t>CI/CD Integration (3 Modes)</a:t>
+              <a:t>Chat</a:t>
             </a:r>
           </a:p>
         </p:txBody>
@@ -6785,181 +6721,109 @@
               </a:defRPr>
             </a:pPr>
             <a:r>
-              <a:t>Mode 1: CLI Headless</a:t>
-            </a:r>
-          </a:p>
-          <a:p>
-            <a:pPr>
-              <a:spcBef>
-                <a:spcPts val="800"/>
-              </a:spcBef>
-              <a:defRPr sz="1800">
-                <a:solidFill>
-                  <a:srgbClr val="F1F5F9"/>
-                </a:solidFill>
-              </a:defRPr>
-            </a:pPr>
-            <a:r>
-              <a:t>• kiro-cli chat --no-interactive "&lt;prompt&gt;" in pipeline</a:t>
-            </a:r>
-          </a:p>
-          <a:p>
-            <a:pPr>
-              <a:spcBef>
-                <a:spcPts val="800"/>
-              </a:spcBef>
-              <a:defRPr sz="1800">
-                <a:solidFill>
-                  <a:srgbClr val="F1F5F9"/>
-                </a:solidFill>
-              </a:defRPr>
-            </a:pPr>
-            <a:r>
-              <a:t>• Engine version: --engine v3 (not --v3)</a:t>
-            </a:r>
-          </a:p>
-          <a:p>
-            <a:pPr>
-              <a:spcBef>
-                <a:spcPts val="800"/>
-              </a:spcBef>
-              <a:defRPr sz="1800">
-                <a:solidFill>
-                  <a:srgbClr val="F1F5F9"/>
-                </a:solidFill>
-              </a:defRPr>
-            </a:pPr>
-            <a:r>
-              <a:t>• Use case: Simple code generation</a:t>
-            </a:r>
-          </a:p>
-          <a:p>
-            <a:pPr>
-              <a:spcBef>
-                <a:spcPts val="800"/>
-              </a:spcBef>
-              <a:defRPr sz="1800">
-                <a:solidFill>
-                  <a:srgbClr val="F1F5F9"/>
-                </a:solidFill>
-              </a:defRPr>
-            </a:pPr>
-          </a:p>
-          <a:p>
-            <a:pPr>
-              <a:spcBef>
-                <a:spcPts val="800"/>
-              </a:spcBef>
-              <a:defRPr sz="1800">
-                <a:solidFill>
-                  <a:srgbClr val="F1F5F9"/>
-                </a:solidFill>
-              </a:defRPr>
-            </a:pPr>
-            <a:r>
-              <a:t>Mode 2: Crew Webhooks</a:t>
-            </a:r>
-          </a:p>
-          <a:p>
-            <a:pPr>
-              <a:spcBef>
-                <a:spcPts val="800"/>
-              </a:spcBef>
-              <a:defRPr sz="1800">
-                <a:solidFill>
-                  <a:srgbClr val="F1F5F9"/>
-                </a:solidFill>
-              </a:defRPr>
-            </a:pPr>
-            <a:r>
-              <a:t>• CI pipeline calls Crew on events</a:t>
-            </a:r>
-          </a:p>
-          <a:p>
-            <a:pPr>
-              <a:spcBef>
-                <a:spcPts val="800"/>
-              </a:spcBef>
-              <a:defRPr sz="1800">
-                <a:solidFill>
-                  <a:srgbClr val="F1F5F9"/>
-                </a:solidFill>
-              </a:defRPr>
-            </a:pPr>
-            <a:r>
-              <a:t>• Crew analyzes and reports via Slack/Dashboard</a:t>
-            </a:r>
-          </a:p>
-          <a:p>
-            <a:pPr>
-              <a:spcBef>
-                <a:spcPts val="800"/>
-              </a:spcBef>
-              <a:defRPr sz="1800">
-                <a:solidFill>
-                  <a:srgbClr val="F1F5F9"/>
-                </a:solidFill>
-              </a:defRPr>
-            </a:pPr>
-            <a:r>
-              <a:t>• Use case: Root cause analysis, monitoring</a:t>
-            </a:r>
-          </a:p>
-          <a:p>
-            <a:pPr>
-              <a:spcBef>
-                <a:spcPts val="800"/>
-              </a:spcBef>
-              <a:defRPr sz="1800">
-                <a:solidFill>
-                  <a:srgbClr val="F1F5F9"/>
-                </a:solidFill>
-              </a:defRPr>
-            </a:pPr>
-          </a:p>
-          <a:p>
-            <a:pPr>
-              <a:spcBef>
-                <a:spcPts val="800"/>
-              </a:spcBef>
-              <a:defRPr sz="1800">
-                <a:solidFill>
-                  <a:srgbClr val="F1F5F9"/>
-                </a:solidFill>
-              </a:defRPr>
-            </a:pPr>
-            <a:r>
-              <a:t>Mode 3: Crew Cron</a:t>
-            </a:r>
-          </a:p>
-          <a:p>
-            <a:pPr>
-              <a:spcBef>
-                <a:spcPts val="800"/>
-              </a:spcBef>
-              <a:defRPr sz="1800">
-                <a:solidFill>
-                  <a:srgbClr val="F1F5F9"/>
-                </a:solidFill>
-              </a:defRPr>
-            </a:pPr>
-            <a:r>
-              <a:t>• Periodic checks of CI/PR status</a:t>
-            </a:r>
-          </a:p>
-          <a:p>
-            <a:pPr>
-              <a:spcBef>
-                <a:spcPts val="800"/>
-              </a:spcBef>
-              <a:defRPr sz="1800">
-                <a:solidFill>
-                  <a:srgbClr val="F1F5F9"/>
-                </a:solidFill>
-              </a:defRPr>
-            </a:pPr>
-            <a:r>
-              <a:t>• Use case: Nightly audits, health checks</a:t>
+              <a:t>Send text / @file / voice; streaming replies with live tool calls</a:t>
+            </a:r>
+          </a:p>
+          <a:p>
+            <a:pPr>
+              <a:spcBef>
+                <a:spcPts val="800"/>
+              </a:spcBef>
+              <a:defRPr sz="1800">
+                <a:solidFill>
+                  <a:srgbClr val="F1F5F9"/>
+                </a:solidFill>
+              </a:defRPr>
+            </a:pPr>
+            <a:r>
+              <a:t>Guide: approve/reject, edit &amp; resend, fork, Autopilot</a:t>
+            </a:r>
+          </a:p>
+          <a:p>
+            <a:pPr>
+              <a:spcBef>
+                <a:spcPts val="800"/>
+              </a:spcBef>
+              <a:defRPr sz="1800">
+                <a:solidFill>
+                  <a:srgbClr val="F1F5F9"/>
+                </a:solidFill>
+              </a:defRPr>
+            </a:pPr>
+            <a:r>
+              <a:t>Each tab = independent session sharing long-term memory</a:t>
+            </a:r>
+          </a:p>
+          <a:p>
+            <a:pPr>
+              <a:spcBef>
+                <a:spcPts val="800"/>
+              </a:spcBef>
+              <a:defRPr sz="1800">
+                <a:solidFill>
+                  <a:srgbClr val="F1F5F9"/>
+                </a:solidFill>
+              </a:defRPr>
+            </a:pPr>
+          </a:p>
+          <a:p>
+            <a:pPr>
+              <a:spcBef>
+                <a:spcPts val="800"/>
+              </a:spcBef>
+              <a:defRPr sz="1800">
+                <a:solidFill>
+                  <a:srgbClr val="F1F5F9"/>
+                </a:solidFill>
+              </a:defRPr>
+            </a:pPr>
+            <a:r>
+              <a:t>@ file picker; drag/paste image (vision); mic STT; Piper TTS</a:t>
+            </a:r>
+          </a:p>
+          <a:p>
+            <a:pPr>
+              <a:spcBef>
+                <a:spcPts val="800"/>
+              </a:spcBef>
+              <a:defRPr sz="1800">
+                <a:solidFill>
+                  <a:srgbClr val="F1F5F9"/>
+                </a:solidFill>
+              </a:defRPr>
+            </a:pPr>
+            <a:r>
+              <a:t>Prompt optimizer (Cmd+Shift+Enter); incognito; switch models;</a:t>
+            </a:r>
+          </a:p>
+          <a:p>
+            <a:pPr>
+              <a:spcBef>
+                <a:spcPts val="800"/>
+              </a:spcBef>
+              <a:defRPr sz="1800">
+                <a:solidFill>
+                  <a:srgbClr val="F1F5F9"/>
+                </a:solidFill>
+              </a:defRPr>
+            </a:pPr>
+            <a:r>
+              <a:t>reasoning effort per message</a:t>
+            </a:r>
+          </a:p>
+          <a:p>
+            <a:pPr>
+              <a:spcBef>
+                <a:spcPts val="800"/>
+              </a:spcBef>
+              <a:defRPr sz="1800">
+                <a:solidFill>
+                  <a:srgbClr val="F1F5F9"/>
+                </a:solidFill>
+              </a:defRPr>
+            </a:pPr>
+            <a:r>
+              <a:t>Leaves: Sessions, Message controls, Optimizer, Voice, Widgets</a:t>
             </a:r>
           </a:p>
         </p:txBody>
@@ -6978,7 +6842,7 @@
     <p:bg>
       <p:bgPr>
         <a:solidFill>
-          <a:srgbClr val="1E293B"/>
+          <a:srgbClr val="0F172A"/>
         </a:solidFill>
         <a:effectLst/>
       </p:bgPr>
@@ -6998,8 +6862,8 @@
         </p:nvSpPr>
         <p:spPr>
           <a:xfrm>
-            <a:off x="914400" y="2743200"/>
-            <a:ext cx="7315200" cy="914400"/>
+            <a:off x="457200" y="365760"/>
+            <a:ext cx="6858000" cy="548640"/>
           </a:xfrm>
           <a:prstGeom prst="rect">
             <a:avLst/>
@@ -7012,15 +6876,178 @@
           </a:bodyPr>
           <a:lstStyle/>
           <a:p>
-            <a:pPr algn="ctr">
-              <a:defRPr sz="4400" b="1">
+            <a:pPr>
+              <a:defRPr sz="3200" b="1">
                 <a:solidFill>
                   <a:srgbClr val="2563EB"/>
                 </a:solidFill>
               </a:defRPr>
             </a:pPr>
             <a:r>
-              <a:t>Part 5: Getting Started</a:t>
+              <a:t>Agent Capabilities (Customization Hub)</a:t>
+            </a:r>
+          </a:p>
+        </p:txBody>
+      </p:sp>
+      <p:sp>
+        <p:nvSpPr>
+          <p:cNvPr id="3" name="TextBox 2"/>
+          <p:cNvSpPr txBox="1"/>
+          <p:nvPr/>
+        </p:nvSpPr>
+        <p:spPr>
+          <a:xfrm>
+            <a:off x="7498079" y="411480"/>
+            <a:ext cx="1371600" cy="365760"/>
+          </a:xfrm>
+          <a:prstGeom prst="rect">
+            <a:avLst/>
+          </a:prstGeom>
+          <a:noFill/>
+        </p:spPr>
+        <p:txBody>
+          <a:bodyPr wrap="none">
+            <a:spAutoFit/>
+          </a:bodyPr>
+          <a:lstStyle/>
+          <a:p>
+            <a:pPr>
+              <a:defRPr sz="1100" b="1">
+                <a:solidFill>
+                  <a:srgbClr val="10B981"/>
+                </a:solidFill>
+              </a:defRPr>
+            </a:pPr>
+            <a:r>
+              <a:t>✓ Verified</a:t>
+            </a:r>
+          </a:p>
+        </p:txBody>
+      </p:sp>
+      <p:sp>
+        <p:nvSpPr>
+          <p:cNvPr id="4" name="TextBox 3"/>
+          <p:cNvSpPr txBox="1"/>
+          <p:nvPr/>
+        </p:nvSpPr>
+        <p:spPr>
+          <a:xfrm>
+            <a:off x="640080" y="1188720"/>
+            <a:ext cx="7863840" cy="5212080"/>
+          </a:xfrm>
+          <a:prstGeom prst="rect">
+            <a:avLst/>
+          </a:prstGeom>
+          <a:noFill/>
+        </p:spPr>
+        <p:txBody>
+          <a:bodyPr wrap="square">
+            <a:spAutoFit/>
+          </a:bodyPr>
+          <a:lstStyle/>
+          <a:p>
+            <a:pPr>
+              <a:spcBef>
+                <a:spcPts val="800"/>
+              </a:spcBef>
+              <a:defRPr sz="1800">
+                <a:solidFill>
+                  <a:srgbClr val="F1F5F9"/>
+                </a:solidFill>
+              </a:defRPr>
+            </a:pPr>
+            <a:r>
+              <a:t>Agents - model/prompt/tools/MCP server config</a:t>
+            </a:r>
+          </a:p>
+          <a:p>
+            <a:pPr>
+              <a:spcBef>
+                <a:spcPts val="800"/>
+              </a:spcBef>
+              <a:defRPr sz="1800">
+                <a:solidFill>
+                  <a:srgbClr val="F1F5F9"/>
+                </a:solidFill>
+              </a:defRPr>
+            </a:pPr>
+            <a:r>
+              <a:t>Agent Templates - prebuilt configs to customize</a:t>
+            </a:r>
+          </a:p>
+          <a:p>
+            <a:pPr>
+              <a:spcBef>
+                <a:spcPts val="800"/>
+              </a:spcBef>
+              <a:defRPr sz="1800">
+                <a:solidFill>
+                  <a:srgbClr val="F1F5F9"/>
+                </a:solidFill>
+              </a:defRPr>
+            </a:pPr>
+            <a:r>
+              <a:t>Integrations (MCP) - add external tools/services</a:t>
+            </a:r>
+          </a:p>
+          <a:p>
+            <a:pPr>
+              <a:spcBef>
+                <a:spcPts val="800"/>
+              </a:spcBef>
+              <a:defRPr sz="1800">
+                <a:solidFill>
+                  <a:srgbClr val="F1F5F9"/>
+                </a:solidFill>
+              </a:defRPr>
+            </a:pPr>
+            <a:r>
+              <a:t>Skills - on-demand knowledge files teaching workflows</a:t>
+            </a:r>
+          </a:p>
+          <a:p>
+            <a:pPr>
+              <a:spcBef>
+                <a:spcPts val="800"/>
+              </a:spcBef>
+              <a:defRPr sz="1800">
+                <a:solidFill>
+                  <a:srgbClr val="F1F5F9"/>
+                </a:solidFill>
+              </a:defRPr>
+            </a:pPr>
+            <a:r>
+              <a:t>Steering - workspace-level rules every session inherits</a:t>
+            </a:r>
+          </a:p>
+          <a:p>
+            <a:pPr>
+              <a:spcBef>
+                <a:spcPts val="800"/>
+              </a:spcBef>
+              <a:defRPr sz="1800">
+                <a:solidFill>
+                  <a:srgbClr val="F1F5F9"/>
+                </a:solidFill>
+              </a:defRPr>
+            </a:pPr>
+            <a:r>
+              <a:t>Hooks - automate reactions to events (scripts/context)</a:t>
+            </a:r>
+          </a:p>
+          <a:p>
+            <a:pPr>
+              <a:spcBef>
+                <a:spcPts val="800"/>
+              </a:spcBef>
+              <a:defRPr sz="1800">
+                <a:solidFill>
+                  <a:srgbClr val="F1F5F9"/>
+                </a:solidFill>
+              </a:defRPr>
+            </a:pPr>
+            <a:r>
+              <a:t>Prompts - customize the system prompts shaping behavior</a:t>
             </a:r>
           </a:p>
         </p:txBody>
@@ -7060,7 +7087,7 @@
         <p:spPr>
           <a:xfrm>
             <a:off x="457200" y="365760"/>
-            <a:ext cx="8229600" cy="548640"/>
+            <a:ext cx="6858000" cy="548640"/>
           </a:xfrm>
           <a:prstGeom prst="rect">
             <a:avLst/>
@@ -7081,7 +7108,7 @@
               </a:defRPr>
             </a:pPr>
             <a:r>
-              <a:t>Installation</a:t>
+              <a:t>Configuration</a:t>
             </a:r>
           </a:p>
         </p:txBody>
@@ -7094,8 +7121,8 @@
         </p:nvSpPr>
         <p:spPr>
           <a:xfrm>
-            <a:off x="457200" y="1188720"/>
-            <a:ext cx="4114800" cy="5212080"/>
+            <a:off x="7498079" y="411480"/>
+            <a:ext cx="1371600" cy="365760"/>
           </a:xfrm>
           <a:prstGeom prst="rect">
             <a:avLst/>
@@ -7103,125 +7130,20 @@
           <a:noFill/>
         </p:spPr>
         <p:txBody>
-          <a:bodyPr wrap="square">
+          <a:bodyPr wrap="none">
             <a:spAutoFit/>
           </a:bodyPr>
           <a:lstStyle/>
           <a:p>
             <a:pPr>
-              <a:spcBef>
-                <a:spcPts val="600"/>
-              </a:spcBef>
-              <a:defRPr sz="1600">
-                <a:solidFill>
-                  <a:srgbClr val="F1F5F9"/>
-                </a:solidFill>
-              </a:defRPr>
-            </a:pPr>
-            <a:r>
-              <a:t>Option 1: Desktop App (Recommended)</a:t>
-            </a:r>
-          </a:p>
-          <a:p>
-            <a:pPr>
-              <a:spcBef>
-                <a:spcPts val="600"/>
-              </a:spcBef>
-              <a:defRPr sz="1600">
-                <a:solidFill>
-                  <a:srgbClr val="F1F5F9"/>
-                </a:solidFill>
-              </a:defRPr>
-            </a:pPr>
-            <a:r>
-              <a:t>1. Download (.dmg or .AppImage)</a:t>
-            </a:r>
-          </a:p>
-          <a:p>
-            <a:pPr>
-              <a:spcBef>
-                <a:spcPts val="600"/>
-              </a:spcBef>
-              <a:defRPr sz="1600">
-                <a:solidFill>
-                  <a:srgbClr val="F1F5F9"/>
-                </a:solidFill>
-              </a:defRPr>
-            </a:pPr>
-            <a:r>
-              <a:t>2. Launch (auto-starts Gateway)</a:t>
-            </a:r>
-          </a:p>
-          <a:p>
-            <a:pPr>
-              <a:spcBef>
-                <a:spcPts val="600"/>
-              </a:spcBef>
-              <a:defRPr sz="1600">
-                <a:solidFill>
-                  <a:srgbClr val="F1F5F9"/>
-                </a:solidFill>
-              </a:defRPr>
-            </a:pPr>
-            <a:r>
-              <a:t>3. Authenticate (device-code sign-in)</a:t>
-            </a:r>
-          </a:p>
-          <a:p>
-            <a:pPr>
-              <a:spcBef>
-                <a:spcPts val="600"/>
-              </a:spcBef>
-              <a:defRPr sz="1600">
-                <a:solidFill>
-                  <a:srgbClr val="F1F5F9"/>
-                </a:solidFill>
-              </a:defRPr>
-            </a:pPr>
-            <a:r>
-              <a:t>4. Start chatting</a:t>
-            </a:r>
-          </a:p>
-          <a:p>
-            <a:pPr>
-              <a:spcBef>
-                <a:spcPts val="600"/>
-              </a:spcBef>
-              <a:defRPr sz="1600">
-                <a:solidFill>
-                  <a:srgbClr val="F1F5F9"/>
-                </a:solidFill>
-              </a:defRPr>
-            </a:pPr>
-          </a:p>
-          <a:p>
-            <a:pPr>
-              <a:spcBef>
-                <a:spcPts val="600"/>
-              </a:spcBef>
-              <a:defRPr sz="1600">
-                <a:solidFill>
-                  <a:srgbClr val="F1F5F9"/>
-                </a:solidFill>
-              </a:defRPr>
-            </a:pPr>
-            <a:r>
-              <a:t>No AWS CLI needed</a:t>
-            </a:r>
-          </a:p>
-          <a:p>
-            <a:pPr>
-              <a:spcBef>
-                <a:spcPts val="600"/>
-              </a:spcBef>
-              <a:defRPr sz="1600">
-                <a:solidFill>
-                  <a:srgbClr val="F1F5F9"/>
-                </a:solidFill>
-              </a:defRPr>
-            </a:pPr>
-            <a:r>
-              <a:t>No Bedrock configuration needed</a:t>
+              <a:defRPr sz="1100" b="1">
+                <a:solidFill>
+                  <a:srgbClr val="10B981"/>
+                </a:solidFill>
+              </a:defRPr>
+            </a:pPr>
+            <a:r>
+              <a:t>✓ Verified</a:t>
             </a:r>
           </a:p>
         </p:txBody>
@@ -7234,8 +7156,8 @@
         </p:nvSpPr>
         <p:spPr>
           <a:xfrm>
-            <a:off x="4754880" y="1188720"/>
-            <a:ext cx="4114800" cy="5212080"/>
+            <a:off x="640080" y="1188720"/>
+            <a:ext cx="7863840" cy="5212080"/>
           </a:xfrm>
           <a:prstGeom prst="rect">
             <a:avLst/>
@@ -7250,115 +7172,118 @@
           <a:p>
             <a:pPr>
               <a:spcBef>
-                <a:spcPts val="600"/>
-              </a:spcBef>
-              <a:defRPr sz="1600">
-                <a:solidFill>
-                  <a:srgbClr val="F1F5F9"/>
-                </a:solidFill>
-              </a:defRPr>
-            </a:pPr>
-            <a:r>
-              <a:t>Option 2: CLI Install</a:t>
-            </a:r>
-          </a:p>
-          <a:p>
-            <a:pPr>
-              <a:spcBef>
-                <a:spcPts val="600"/>
-              </a:spcBef>
-              <a:defRPr sz="1600">
-                <a:solidFill>
-                  <a:srgbClr val="F1F5F9"/>
-                </a:solidFill>
-              </a:defRPr>
-            </a:pPr>
-            <a:r>
-              <a:t>curl -fsSL https://download.crew.kiro.dev/cli.sh | sh</a:t>
-            </a:r>
-          </a:p>
-          <a:p>
-            <a:pPr>
-              <a:spcBef>
-                <a:spcPts val="600"/>
-              </a:spcBef>
-              <a:defRPr sz="1600">
-                <a:solidFill>
-                  <a:srgbClr val="F1F5F9"/>
-                </a:solidFill>
-              </a:defRPr>
-            </a:pPr>
-          </a:p>
-          <a:p>
-            <a:pPr>
-              <a:spcBef>
-                <a:spcPts val="600"/>
-              </a:spcBef>
-              <a:defRPr sz="1600">
-                <a:solidFill>
-                  <a:srgbClr val="F1F5F9"/>
-                </a:solidFill>
-              </a:defRPr>
-            </a:pPr>
-            <a:r>
-              <a:t>kirocrew setup</a:t>
-            </a:r>
-          </a:p>
-          <a:p>
-            <a:pPr>
-              <a:spcBef>
-                <a:spcPts val="600"/>
-              </a:spcBef>
-              <a:defRPr sz="1600">
-                <a:solidFill>
-                  <a:srgbClr val="F1F5F9"/>
-                </a:solidFill>
-              </a:defRPr>
-            </a:pPr>
-            <a:r>
-              <a:t>kirocrew doctor</a:t>
-            </a:r>
-          </a:p>
-          <a:p>
-            <a:pPr>
-              <a:spcBef>
-                <a:spcPts val="600"/>
-              </a:spcBef>
-              <a:defRPr sz="1600">
-                <a:solidFill>
-                  <a:srgbClr val="F1F5F9"/>
-                </a:solidFill>
-              </a:defRPr>
-            </a:pPr>
-            <a:r>
-              <a:t>kirocrew gateway</a:t>
-            </a:r>
-          </a:p>
-          <a:p>
-            <a:pPr>
-              <a:spcBef>
-                <a:spcPts val="600"/>
-              </a:spcBef>
-              <a:defRPr sz="1600">
-                <a:solidFill>
-                  <a:srgbClr val="F1F5F9"/>
-                </a:solidFill>
-              </a:defRPr>
-            </a:pPr>
-          </a:p>
-          <a:p>
-            <a:pPr>
-              <a:spcBef>
-                <a:spcPts val="600"/>
-              </a:spcBef>
-              <a:defRPr sz="1600">
-                <a:solidFill>
-                  <a:srgbClr val="F1F5F9"/>
-                </a:solidFill>
-              </a:defRPr>
-            </a:pPr>
-            <a:r>
-              <a:t>open http://localhost:5476</a:t>
+                <a:spcPts val="800"/>
+              </a:spcBef>
+              <a:defRPr sz="1800">
+                <a:solidFill>
+                  <a:srgbClr val="F1F5F9"/>
+                </a:solidFill>
+              </a:defRPr>
+            </a:pPr>
+            <a:r>
+              <a:t>Settings panel: Overview/Imports/Chat/Display/Voice/</a:t>
+            </a:r>
+          </a:p>
+          <a:p>
+            <a:pPr>
+              <a:spcBef>
+                <a:spcPts val="800"/>
+              </a:spcBef>
+              <a:defRPr sz="1800">
+                <a:solidFill>
+                  <a:srgbClr val="F1F5F9"/>
+                </a:solidFill>
+              </a:defRPr>
+            </a:pPr>
+            <a:r>
+              <a:t>Notifications/Shortcuts/Skills/Channels/Browser/Computer Use/</a:t>
+            </a:r>
+          </a:p>
+          <a:p>
+            <a:pPr>
+              <a:spcBef>
+                <a:spcPts val="800"/>
+              </a:spcBef>
+              <a:defRPr sz="1800">
+                <a:solidFill>
+                  <a:srgbClr val="F1F5F9"/>
+                </a:solidFill>
+              </a:defRPr>
+            </a:pPr>
+            <a:r>
+              <a:t>Instances/Security/Developer/About - changes apply immediately</a:t>
+            </a:r>
+          </a:p>
+          <a:p>
+            <a:pPr>
+              <a:spcBef>
+                <a:spcPts val="800"/>
+              </a:spcBef>
+              <a:defRPr sz="1800">
+                <a:solidFill>
+                  <a:srgbClr val="F1F5F9"/>
+                </a:solidFill>
+              </a:defRPr>
+            </a:pPr>
+          </a:p>
+          <a:p>
+            <a:pPr>
+              <a:spcBef>
+                <a:spcPts val="800"/>
+              </a:spcBef>
+              <a:defRPr sz="1800">
+                <a:solidFill>
+                  <a:srgbClr val="F1F5F9"/>
+                </a:solidFill>
+              </a:defRPr>
+            </a:pPr>
+            <a:r>
+              <a:t>kirocrew config get|set|edit (set auto-restarts pool)</a:t>
+            </a:r>
+          </a:p>
+          <a:p>
+            <a:pPr>
+              <a:spcBef>
+                <a:spcPts val="800"/>
+              </a:spcBef>
+              <a:defRPr sz="1800">
+                <a:solidFill>
+                  <a:srgbClr val="F1F5F9"/>
+                </a:solidFill>
+              </a:defRPr>
+            </a:pPr>
+            <a:r>
+              <a:t>config.json (JSON, missing keys -&gt; defaults); 14 themes</a:t>
+            </a:r>
+          </a:p>
+          <a:p>
+            <a:pPr>
+              <a:spcBef>
+                <a:spcPts val="800"/>
+              </a:spcBef>
+              <a:defRPr sz="1800">
+                <a:solidFill>
+                  <a:srgbClr val="F1F5F9"/>
+                </a:solidFill>
+              </a:defRPr>
+            </a:pPr>
+            <a:r>
+              <a:t>Channel creds in ~/.kiro/crew/.env (mode 600)</a:t>
+            </a:r>
+          </a:p>
+          <a:p>
+            <a:pPr>
+              <a:spcBef>
+                <a:spcPts val="800"/>
+              </a:spcBef>
+              <a:defRPr sz="1800">
+                <a:solidFill>
+                  <a:srgbClr val="F1F5F9"/>
+                </a:solidFill>
+              </a:defRPr>
+            </a:pPr>
+            <a:r>
+              <a:t>Env: KIROCREW_HOME (~/.kiro/crew), KIROCREW_PORT (5476)</a:t>
             </a:r>
           </a:p>
         </p:txBody>
@@ -7419,7 +7344,7 @@
               </a:defRPr>
             </a:pPr>
             <a:r>
-              <a:t>First Steps</a:t>
+              <a:t>Multi-instance</a:t>
             </a:r>
           </a:p>
         </p:txBody>
@@ -7492,115 +7417,109 @@
               </a:defRPr>
             </a:pPr>
             <a:r>
-              <a:t>1. Chat - Type and ask anything in dashboard</a:t>
-            </a:r>
-          </a:p>
-          <a:p>
-            <a:pPr>
-              <a:spcBef>
-                <a:spcPts val="800"/>
-              </a:spcBef>
-              <a:defRPr sz="1800">
-                <a:solidFill>
-                  <a:srgbClr val="F1F5F9"/>
-                </a:solidFill>
-              </a:defRPr>
-            </a:pPr>
-          </a:p>
-          <a:p>
-            <a:pPr>
-              <a:spcBef>
-                <a:spcPts val="800"/>
-              </a:spcBef>
-              <a:defRPr sz="1800">
-                <a:solidFill>
-                  <a:srgbClr val="F1F5F9"/>
-                </a:solidFill>
-              </a:defRPr>
-            </a:pPr>
-            <a:r>
-              <a:t>2. Schedule a job - 'Every weekday at 9, summarize my open work'</a:t>
-            </a:r>
-          </a:p>
-          <a:p>
-            <a:pPr>
-              <a:spcBef>
-                <a:spcPts val="800"/>
-              </a:spcBef>
-              <a:defRPr sz="1800">
-                <a:solidFill>
-                  <a:srgbClr val="F1F5F9"/>
-                </a:solidFill>
-              </a:defRPr>
-            </a:pPr>
-          </a:p>
-          <a:p>
-            <a:pPr>
-              <a:spcBef>
-                <a:spcPts val="800"/>
-              </a:spcBef>
-              <a:defRPr sz="1800">
-                <a:solidFill>
-                  <a:srgbClr val="F1F5F9"/>
-                </a:solidFill>
-              </a:defRPr>
-            </a:pPr>
-            <a:r>
-              <a:t>3. Teach a preference - 'Always use pytest over unittest'</a:t>
-            </a:r>
-          </a:p>
-          <a:p>
-            <a:pPr>
-              <a:spcBef>
-                <a:spcPts val="800"/>
-              </a:spcBef>
-              <a:defRPr sz="1800">
-                <a:solidFill>
-                  <a:srgbClr val="F1F5F9"/>
-                </a:solidFill>
-              </a:defRPr>
-            </a:pPr>
-          </a:p>
-          <a:p>
-            <a:pPr>
-              <a:spcBef>
-                <a:spcPts val="800"/>
-              </a:spcBef>
-              <a:defRPr sz="1800">
-                <a:solidFill>
-                  <a:srgbClr val="F1F5F9"/>
-                </a:solidFill>
-              </a:defRPr>
-            </a:pPr>
-            <a:r>
-              <a:t>4. Run autonomous task - Projects panel → describe spec → Run</a:t>
-            </a:r>
-          </a:p>
-          <a:p>
-            <a:pPr>
-              <a:spcBef>
-                <a:spcPts val="800"/>
-              </a:spcBef>
-              <a:defRPr sz="1800">
-                <a:solidFill>
-                  <a:srgbClr val="F1F5F9"/>
-                </a:solidFill>
-              </a:defRPr>
-            </a:pPr>
-          </a:p>
-          <a:p>
-            <a:pPr>
-              <a:spcBef>
-                <a:spcPts val="800"/>
-              </a:spcBef>
-              <a:defRPr sz="1800">
-                <a:solidFill>
-                  <a:srgbClr val="F1F5F9"/>
-                </a:solidFill>
-              </a:defRPr>
-            </a:pPr>
-            <a:r>
-              <a:t>5. Delegate parallel work - 'Research these 3 options in parallel'</a:t>
+              <a:t>Drive multiple remote Crew hosts from one hub via SSH tunnels</a:t>
+            </a:r>
+          </a:p>
+          <a:p>
+            <a:pPr>
+              <a:spcBef>
+                <a:spcPts val="800"/>
+              </a:spcBef>
+              <a:defRPr sz="1800">
+                <a:solidFill>
+                  <a:srgbClr val="F1F5F9"/>
+                </a:solidFill>
+              </a:defRPr>
+            </a:pPr>
+            <a:r>
+              <a:t>Opt-in, off by default:</a:t>
+            </a:r>
+          </a:p>
+          <a:p>
+            <a:pPr>
+              <a:spcBef>
+                <a:spcPts val="800"/>
+              </a:spcBef>
+              <a:defRPr sz="1800">
+                <a:solidFill>
+                  <a:srgbClr val="F1F5F9"/>
+                </a:solidFill>
+              </a:defRPr>
+            </a:pPr>
+            <a:r>
+              <a:t>  kirocrew config set instances.enabled true &amp;&amp; kirocrew restart</a:t>
+            </a:r>
+          </a:p>
+          <a:p>
+            <a:pPr>
+              <a:spcBef>
+                <a:spcPts val="800"/>
+              </a:spcBef>
+              <a:defRPr sz="1800">
+                <a:solidFill>
+                  <a:srgbClr val="F1F5F9"/>
+                </a:solidFill>
+              </a:defRPr>
+            </a:pPr>
+          </a:p>
+          <a:p>
+            <a:pPr>
+              <a:spcBef>
+                <a:spcPts val="800"/>
+              </a:spcBef>
+              <a:defRPr sz="1800">
+                <a:solidFill>
+                  <a:srgbClr val="F1F5F9"/>
+                </a:solidFill>
+              </a:defRPr>
+            </a:pPr>
+            <a:r>
+              <a:t>Warm set cap 5 (LRU); health probe 30s; 2-tier self-heal (&lt;=8)</a:t>
+            </a:r>
+          </a:p>
+          <a:p>
+            <a:pPr>
+              <a:spcBef>
+                <a:spcPts val="800"/>
+              </a:spcBef>
+              <a:defRPr sz="1800">
+                <a:solidFill>
+                  <a:srgbClr val="F1F5F9"/>
+                </a:solidFill>
+              </a:defRPr>
+            </a:pPr>
+            <a:r>
+              <a:t>Add: SSH host/alias, remote port 7777, token TTL 20h</a:t>
+            </a:r>
+          </a:p>
+          <a:p>
+            <a:pPr>
+              <a:spcBef>
+                <a:spcPts val="800"/>
+              </a:spcBef>
+              <a:defRPr sz="1800">
+                <a:solidFill>
+                  <a:srgbClr val="F1F5F9"/>
+                </a:solidFill>
+              </a:defRPr>
+            </a:pPr>
+            <a:r>
+              <a:t>Security: deny-by-default, owner-only, loopback forwards,</a:t>
+            </a:r>
+          </a:p>
+          <a:p>
+            <a:pPr>
+              <a:spcBef>
+                <a:spcPts val="800"/>
+              </a:spcBef>
+              <a:defRPr sz="1800">
+                <a:solidFill>
+                  <a:srgbClr val="F1F5F9"/>
+                </a:solidFill>
+              </a:defRPr>
+            </a:pPr>
+            <a:r>
+              <a:t>argv-list ssh (no shell injection), SEL-audited</a:t>
             </a:r>
           </a:p>
         </p:txBody>
@@ -7661,7 +7580,7 @@
               </a:defRPr>
             </a:pPr>
             <a:r>
-              <a:t>Resources</a:t>
+              <a:t>Snapshot &amp; Restore</a:t>
             </a:r>
           </a:p>
         </p:txBody>
@@ -7734,151 +7653,109 @@
               </a:defRPr>
             </a:pPr>
             <a:r>
-              <a:t>Official Documentation:</a:t>
-            </a:r>
-          </a:p>
-          <a:p>
-            <a:pPr>
-              <a:spcBef>
-                <a:spcPts val="800"/>
-              </a:spcBef>
-              <a:defRPr sz="1800">
-                <a:solidFill>
-                  <a:srgbClr val="F1F5F9"/>
-                </a:solidFill>
-              </a:defRPr>
-            </a:pPr>
-            <a:r>
-              <a:t>• kiro.dev/docs/crew/ - Main docs</a:t>
-            </a:r>
-          </a:p>
-          <a:p>
-            <a:pPr>
-              <a:spcBef>
-                <a:spcPts val="800"/>
-              </a:spcBef>
-              <a:defRPr sz="1800">
-                <a:solidFill>
-                  <a:srgbClr val="F1F5F9"/>
-                </a:solidFill>
-              </a:defRPr>
-            </a:pPr>
-            <a:r>
-              <a:t>• kiro.dev/docs/crew/installation/ - Setup</a:t>
-            </a:r>
-          </a:p>
-          <a:p>
-            <a:pPr>
-              <a:spcBef>
-                <a:spcPts val="800"/>
-              </a:spcBef>
-              <a:defRPr sz="1800">
-                <a:solidFill>
-                  <a:srgbClr val="F1F5F9"/>
-                </a:solidFill>
-              </a:defRPr>
-            </a:pPr>
-            <a:r>
-              <a:t>• kiro.dev/docs/crew/features/ - Features</a:t>
-            </a:r>
-          </a:p>
-          <a:p>
-            <a:pPr>
-              <a:spcBef>
-                <a:spcPts val="800"/>
-              </a:spcBef>
-              <a:defRPr sz="1800">
-                <a:solidFill>
-                  <a:srgbClr val="F1F5F9"/>
-                </a:solidFill>
-              </a:defRPr>
-            </a:pPr>
-          </a:p>
-          <a:p>
-            <a:pPr>
-              <a:spcBef>
-                <a:spcPts val="800"/>
-              </a:spcBef>
-              <a:defRPr sz="1800">
-                <a:solidFill>
-                  <a:srgbClr val="F1F5F9"/>
-                </a:solidFill>
-              </a:defRPr>
-            </a:pPr>
-            <a:r>
-              <a:t>Specific Features:</a:t>
-            </a:r>
-          </a:p>
-          <a:p>
-            <a:pPr>
-              <a:spcBef>
-                <a:spcPts val="800"/>
-              </a:spcBef>
-              <a:defRPr sz="1800">
-                <a:solidFill>
-                  <a:srgbClr val="F1F5F9"/>
-                </a:solidFill>
-              </a:defRPr>
-            </a:pPr>
-            <a:r>
-              <a:t>• kiro.dev/docs/crew/features/memory/ - Memory</a:t>
-            </a:r>
-          </a:p>
-          <a:p>
-            <a:pPr>
-              <a:spcBef>
-                <a:spcPts val="800"/>
-              </a:spcBef>
-              <a:defRPr sz="1800">
-                <a:solidFill>
-                  <a:srgbClr val="F1F5F9"/>
-                </a:solidFill>
-              </a:defRPr>
-            </a:pPr>
-            <a:r>
-              <a:t>• kiro.dev/docs/crew/features/subagents/ - Subagents</a:t>
-            </a:r>
-          </a:p>
-          <a:p>
-            <a:pPr>
-              <a:spcBef>
-                <a:spcPts val="800"/>
-              </a:spcBef>
-              <a:defRPr sz="1800">
-                <a:solidFill>
-                  <a:srgbClr val="F1F5F9"/>
-                </a:solidFill>
-              </a:defRPr>
-            </a:pPr>
-            <a:r>
-              <a:t>• kiro.dev/docs/crew/features/cron/ - Scheduling</a:t>
-            </a:r>
-          </a:p>
-          <a:p>
-            <a:pPr>
-              <a:spcBef>
-                <a:spcPts val="800"/>
-              </a:spcBef>
-              <a:defRPr sz="1800">
-                <a:solidFill>
-                  <a:srgbClr val="F1F5F9"/>
-                </a:solidFill>
-              </a:defRPr>
-            </a:pPr>
-          </a:p>
-          <a:p>
-            <a:pPr>
-              <a:spcBef>
-                <a:spcPts val="800"/>
-              </a:spcBef>
-              <a:defRPr sz="1800">
-                <a:solidFill>
-                  <a:srgbClr val="F1F5F9"/>
-                </a:solidFill>
-              </a:defRPr>
-            </a:pPr>
-            <a:r>
-              <a:t>Pricing: kiro.dev/pricing/</a:t>
+              <a:t>kirocrew snapshot [dir] --keep N | --list</a:t>
+            </a:r>
+          </a:p>
+          <a:p>
+            <a:pPr>
+              <a:spcBef>
+                <a:spcPts val="800"/>
+              </a:spcBef>
+              <a:defRPr sz="1800">
+                <a:solidFill>
+                  <a:srgbClr val="F1F5F9"/>
+                </a:solidFill>
+              </a:defRPr>
+            </a:pPr>
+            <a:r>
+              <a:t>kirocrew restore snap.tar.gz [--components ...] [--dry-run]</a:t>
+            </a:r>
+          </a:p>
+          <a:p>
+            <a:pPr>
+              <a:spcBef>
+                <a:spcPts val="800"/>
+              </a:spcBef>
+              <a:defRPr sz="1800">
+                <a:solidFill>
+                  <a:srgbClr val="F1F5F9"/>
+                </a:solidFill>
+              </a:defRPr>
+            </a:pPr>
+          </a:p>
+          <a:p>
+            <a:pPr>
+              <a:spcBef>
+                <a:spcPts val="800"/>
+              </a:spcBef>
+              <a:defRPr sz="1800">
+                <a:solidFill>
+                  <a:srgbClr val="F1F5F9"/>
+                </a:solidFill>
+              </a:defRPr>
+            </a:pPr>
+            <a:r>
+              <a:t>Includes: Memory, Workspace, Crons, Config, Skills, Notifications</a:t>
+            </a:r>
+          </a:p>
+          <a:p>
+            <a:pPr>
+              <a:spcBef>
+                <a:spcPts val="800"/>
+              </a:spcBef>
+              <a:defRPr sz="1800">
+                <a:solidFill>
+                  <a:srgbClr val="F1F5F9"/>
+                </a:solidFill>
+              </a:defRPr>
+            </a:pPr>
+            <a:r>
+              <a:t>Restore modes: replace (empty) vs merge (existing) - auto-detected</a:t>
+            </a:r>
+          </a:p>
+          <a:p>
+            <a:pPr>
+              <a:spcBef>
+                <a:spcPts val="800"/>
+              </a:spcBef>
+              <a:defRPr sz="1800">
+                <a:solidFill>
+                  <a:srgbClr val="F1F5F9"/>
+                </a:solidFill>
+              </a:defRPr>
+            </a:pPr>
+            <a:r>
+              <a:t>Daily auto snapshot 08:00 UTC, keeps 7</a:t>
+            </a:r>
+          </a:p>
+          <a:p>
+            <a:pPr>
+              <a:spcBef>
+                <a:spcPts val="800"/>
+              </a:spcBef>
+              <a:defRPr sz="1800">
+                <a:solidFill>
+                  <a:srgbClr val="F1F5F9"/>
+                </a:solidFill>
+              </a:defRPr>
+            </a:pPr>
+            <a:r>
+              <a:t>Contains security keys - treat like credentials</a:t>
+            </a:r>
+          </a:p>
+          <a:p>
+            <a:pPr>
+              <a:spcBef>
+                <a:spcPts val="800"/>
+              </a:spcBef>
+              <a:defRPr sz="1800">
+                <a:solidFill>
+                  <a:srgbClr val="F1F5F9"/>
+                </a:solidFill>
+              </a:defRPr>
+            </a:pPr>
+            <a:r>
+              <a:t>NOT covered: kiro-cli/AWS creds, channel defs, app code</a:t>
             </a:r>
           </a:p>
         </p:txBody>
@@ -7917,8 +7794,8 @@
         </p:nvSpPr>
         <p:spPr>
           <a:xfrm>
-            <a:off x="914400" y="2286000"/>
-            <a:ext cx="7315200" cy="914400"/>
+            <a:off x="457200" y="365760"/>
+            <a:ext cx="6858000" cy="548640"/>
           </a:xfrm>
           <a:prstGeom prst="rect">
             <a:avLst/>
@@ -7931,15 +7808,15 @@
           </a:bodyPr>
           <a:lstStyle/>
           <a:p>
-            <a:pPr algn="ctr">
-              <a:defRPr sz="5400" b="1">
-                <a:solidFill>
-                  <a:srgbClr val="F1F5F9"/>
-                </a:solidFill>
-              </a:defRPr>
-            </a:pPr>
-            <a:r>
-              <a:t>Questions?</a:t>
+            <a:pPr>
+              <a:defRPr sz="3200" b="1">
+                <a:solidFill>
+                  <a:srgbClr val="2563EB"/>
+                </a:solidFill>
+              </a:defRPr>
+            </a:pPr>
+            <a:r>
+              <a:t>Apps / App Kit</a:t>
             </a:r>
           </a:p>
         </p:txBody>
@@ -7952,8 +7829,8 @@
         </p:nvSpPr>
         <p:spPr>
           <a:xfrm>
-            <a:off x="914400" y="3383280"/>
-            <a:ext cx="7315200" cy="731520"/>
+            <a:off x="7498079" y="411480"/>
+            <a:ext cx="1371600" cy="365760"/>
           </a:xfrm>
           <a:prstGeom prst="rect">
             <a:avLst/>
@@ -7966,15 +7843,15 @@
           </a:bodyPr>
           <a:lstStyle/>
           <a:p>
-            <a:pPr algn="ctr">
-              <a:defRPr sz="2400">
-                <a:solidFill>
-                  <a:srgbClr val="94A3B8"/>
-                </a:solidFill>
-              </a:defRPr>
-            </a:pPr>
-            <a:r>
-              <a:t>Thank you for your attention</a:t>
+            <a:pPr>
+              <a:defRPr sz="1100" b="1">
+                <a:solidFill>
+                  <a:srgbClr val="10B981"/>
+                </a:solidFill>
+              </a:defRPr>
+            </a:pPr>
+            <a:r>
+              <a:t>✓ Verified</a:t>
             </a:r>
           </a:p>
         </p:txBody>
@@ -7987,8 +7864,8 @@
         </p:nvSpPr>
         <p:spPr>
           <a:xfrm>
-            <a:off x="914400" y="5943600"/>
-            <a:ext cx="7315200" cy="457200"/>
+            <a:off x="640080" y="1188720"/>
+            <a:ext cx="7863840" cy="5212080"/>
           </a:xfrm>
           <a:prstGeom prst="rect">
             <a:avLst/>
@@ -7996,20 +7873,125 @@
           <a:noFill/>
         </p:spPr>
         <p:txBody>
-          <a:bodyPr wrap="none">
+          <a:bodyPr wrap="square">
             <a:spAutoFit/>
           </a:bodyPr>
           <a:lstStyle/>
           <a:p>
-            <a:pPr algn="ctr">
-              <a:defRPr sz="1400">
-                <a:solidFill>
-                  <a:srgbClr val="06B6D4"/>
-                </a:solidFill>
-              </a:defRPr>
-            </a:pPr>
-            <a:r>
-              <a:t>✓ All facts sourced from official docs | Verified 2026-08-31</a:t>
+            <a:pPr>
+              <a:spcBef>
+                <a:spcPts val="800"/>
+              </a:spcBef>
+              <a:defRPr sz="1800">
+                <a:solidFill>
+                  <a:srgbClr val="F1F5F9"/>
+                </a:solidFill>
+              </a:defRPr>
+            </a:pPr>
+            <a:r>
+              <a:t>Apps contribute: agents, skills, MCP servers, crons, UI pages,</a:t>
+            </a:r>
+          </a:p>
+          <a:p>
+            <a:pPr>
+              <a:spcBef>
+                <a:spcPts val="800"/>
+              </a:spcBef>
+              <a:defRPr sz="1800">
+                <a:solidFill>
+                  <a:srgbClr val="F1F5F9"/>
+                </a:solidFill>
+              </a:defRPr>
+            </a:pPr>
+            <a:r>
+              <a:t>backend processes, gateway hooks</a:t>
+            </a:r>
+          </a:p>
+          <a:p>
+            <a:pPr>
+              <a:spcBef>
+                <a:spcPts val="800"/>
+              </a:spcBef>
+              <a:defRPr sz="1800">
+                <a:solidFill>
+                  <a:srgbClr val="F1F5F9"/>
+                </a:solidFill>
+              </a:defRPr>
+            </a:pPr>
+            <a:r>
+              <a:t>Third-party apps DISABLED by default (Settings -&gt; Security)</a:t>
+            </a:r>
+          </a:p>
+          <a:p>
+            <a:pPr>
+              <a:spcBef>
+                <a:spcPts val="800"/>
+              </a:spcBef>
+              <a:defRPr sz="1800">
+                <a:solidFill>
+                  <a:srgbClr val="F1F5F9"/>
+                </a:solidFill>
+              </a:defRPr>
+            </a:pPr>
+          </a:p>
+          <a:p>
+            <a:pPr>
+              <a:spcBef>
+                <a:spcPts val="800"/>
+              </a:spcBef>
+              <a:defRPr sz="1800">
+                <a:solidFill>
+                  <a:srgbClr val="F1F5F9"/>
+                </a:solidFill>
+              </a:defRPr>
+            </a:pPr>
+            <a:r>
+              <a:t>Install from App Store (curated registry, PR to add) or</a:t>
+            </a:r>
+          </a:p>
+          <a:p>
+            <a:pPr>
+              <a:spcBef>
+                <a:spcPts val="800"/>
+              </a:spcBef>
+              <a:defRPr sz="1800">
+                <a:solidFill>
+                  <a:srgbClr val="F1F5F9"/>
+                </a:solidFill>
+              </a:defRPr>
+            </a:pPr>
+            <a:r>
+              <a:t>federated external registries (opt-in)</a:t>
+            </a:r>
+          </a:p>
+          <a:p>
+            <a:pPr>
+              <a:spcBef>
+                <a:spcPts val="800"/>
+              </a:spcBef>
+              <a:defRPr sz="1800">
+                <a:solidFill>
+                  <a:srgbClr val="F1F5F9"/>
+                </a:solidFill>
+              </a:defRPr>
+            </a:pPr>
+            <a:r>
+              <a:t>Lifecycle: gateway-managed / app-managed / locked</a:t>
+            </a:r>
+          </a:p>
+          <a:p>
+            <a:pPr>
+              <a:spcBef>
+                <a:spcPts val="800"/>
+              </a:spcBef>
+              <a:defRPr sz="1800">
+                <a:solidFill>
+                  <a:srgbClr val="F1F5F9"/>
+                </a:solidFill>
+              </a:defRPr>
+            </a:pPr>
+            <a:r>
+              <a:t>Dev: kirocrew app dev &lt;name&gt;; only permissions.api enforced</a:t>
             </a:r>
           </a:p>
         </p:txBody>
@@ -8270,6 +8252,2366 @@
 </p:sld>
 </file>
 
+<file path=ppt/slides/slide30.xml><?xml version="1.0" encoding="utf-8"?>
+<p:sld xmlns:a="http://schemas.openxmlformats.org/drawingml/2006/main" xmlns:p="http://schemas.openxmlformats.org/presentationml/2006/main" xmlns:r="http://schemas.openxmlformats.org/officeDocument/2006/relationships">
+  <p:cSld>
+    <p:bg>
+      <p:bgPr>
+        <a:solidFill>
+          <a:srgbClr val="0F172A"/>
+        </a:solidFill>
+        <a:effectLst/>
+      </p:bgPr>
+    </p:bg>
+    <p:spTree>
+      <p:nvGrpSpPr>
+        <p:cNvPr id="1" name=""/>
+        <p:cNvGrpSpPr/>
+        <p:nvPr/>
+      </p:nvGrpSpPr>
+      <p:grpSpPr/>
+      <p:sp>
+        <p:nvSpPr>
+          <p:cNvPr id="2" name="TextBox 1"/>
+          <p:cNvSpPr txBox="1"/>
+          <p:nvPr/>
+        </p:nvSpPr>
+        <p:spPr>
+          <a:xfrm>
+            <a:off x="457200" y="365760"/>
+            <a:ext cx="6858000" cy="548640"/>
+          </a:xfrm>
+          <a:prstGeom prst="rect">
+            <a:avLst/>
+          </a:prstGeom>
+          <a:noFill/>
+        </p:spPr>
+        <p:txBody>
+          <a:bodyPr wrap="none">
+            <a:spAutoFit/>
+          </a:bodyPr>
+          <a:lstStyle/>
+          <a:p>
+            <a:pPr>
+              <a:defRPr sz="3200" b="1">
+                <a:solidFill>
+                  <a:srgbClr val="2563EB"/>
+                </a:solidFill>
+              </a:defRPr>
+            </a:pPr>
+            <a:r>
+              <a:t>Troubleshooting</a:t>
+            </a:r>
+          </a:p>
+        </p:txBody>
+      </p:sp>
+      <p:sp>
+        <p:nvSpPr>
+          <p:cNvPr id="3" name="TextBox 2"/>
+          <p:cNvSpPr txBox="1"/>
+          <p:nvPr/>
+        </p:nvSpPr>
+        <p:spPr>
+          <a:xfrm>
+            <a:off x="7498079" y="411480"/>
+            <a:ext cx="1371600" cy="365760"/>
+          </a:xfrm>
+          <a:prstGeom prst="rect">
+            <a:avLst/>
+          </a:prstGeom>
+          <a:noFill/>
+        </p:spPr>
+        <p:txBody>
+          <a:bodyPr wrap="none">
+            <a:spAutoFit/>
+          </a:bodyPr>
+          <a:lstStyle/>
+          <a:p>
+            <a:pPr>
+              <a:defRPr sz="1100" b="1">
+                <a:solidFill>
+                  <a:srgbClr val="10B981"/>
+                </a:solidFill>
+              </a:defRPr>
+            </a:pPr>
+            <a:r>
+              <a:t>✓ Verified</a:t>
+            </a:r>
+          </a:p>
+        </p:txBody>
+      </p:sp>
+      <p:sp>
+        <p:nvSpPr>
+          <p:cNvPr id="4" name="TextBox 3"/>
+          <p:cNvSpPr txBox="1"/>
+          <p:nvPr/>
+        </p:nvSpPr>
+        <p:spPr>
+          <a:xfrm>
+            <a:off x="640080" y="1188720"/>
+            <a:ext cx="7863840" cy="5212080"/>
+          </a:xfrm>
+          <a:prstGeom prst="rect">
+            <a:avLst/>
+          </a:prstGeom>
+          <a:noFill/>
+        </p:spPr>
+        <p:txBody>
+          <a:bodyPr wrap="square">
+            <a:spAutoFit/>
+          </a:bodyPr>
+          <a:lstStyle/>
+          <a:p>
+            <a:pPr>
+              <a:spcBef>
+                <a:spcPts val="800"/>
+              </a:spcBef>
+              <a:defRPr sz="1800">
+                <a:solidFill>
+                  <a:srgbClr val="F1F5F9"/>
+                </a:solidFill>
+              </a:defRPr>
+            </a:pPr>
+            <a:r>
+              <a:t>Start with a health check:</a:t>
+            </a:r>
+          </a:p>
+          <a:p>
+            <a:pPr>
+              <a:spcBef>
+                <a:spcPts val="800"/>
+              </a:spcBef>
+              <a:defRPr sz="1800">
+                <a:solidFill>
+                  <a:srgbClr val="F1F5F9"/>
+                </a:solidFill>
+              </a:defRPr>
+            </a:pPr>
+            <a:r>
+              <a:t>  kirocrew doctor [--verbose]   /   kirocrew logs -f</a:t>
+            </a:r>
+          </a:p>
+          <a:p>
+            <a:pPr>
+              <a:spcBef>
+                <a:spcPts val="800"/>
+              </a:spcBef>
+              <a:defRPr sz="1800">
+                <a:solidFill>
+                  <a:srgbClr val="F1F5F9"/>
+                </a:solidFill>
+              </a:defRPr>
+            </a:pPr>
+            <a:r>
+              <a:t>Reports: kiro-cli, auth, embeddings, Slack, config, MCP</a:t>
+            </a:r>
+          </a:p>
+          <a:p>
+            <a:pPr>
+              <a:spcBef>
+                <a:spcPts val="800"/>
+              </a:spcBef>
+              <a:defRPr sz="1800">
+                <a:solidFill>
+                  <a:srgbClr val="F1F5F9"/>
+                </a:solidFill>
+              </a:defRPr>
+            </a:pPr>
+          </a:p>
+          <a:p>
+            <a:pPr>
+              <a:spcBef>
+                <a:spcPts val="800"/>
+              </a:spcBef>
+              <a:defRPr sz="1800">
+                <a:solidFill>
+                  <a:srgbClr val="F1F5F9"/>
+                </a:solidFill>
+              </a:defRPr>
+            </a:pPr>
+            <a:r>
+              <a:t>Categories: install/setup, agent (AcpTimeoutError/</a:t>
+            </a:r>
+          </a:p>
+          <a:p>
+            <a:pPr>
+              <a:spcBef>
+                <a:spcPts val="800"/>
+              </a:spcBef>
+              <a:defRPr sz="1800">
+                <a:solidFill>
+                  <a:srgbClr val="F1F5F9"/>
+                </a:solidFill>
+              </a:defRPr>
+            </a:pPr>
+            <a:r>
+              <a:t>AcpProcessDied), memory/embeddings, Slack, Discord, MCP,</a:t>
+            </a:r>
+          </a:p>
+          <a:p>
+            <a:pPr>
+              <a:spcBef>
+                <a:spcPts val="800"/>
+              </a:spcBef>
+              <a:defRPr sz="1800">
+                <a:solidFill>
+                  <a:srgbClr val="F1F5F9"/>
+                </a:solidFill>
+              </a:defRPr>
+            </a:pPr>
+            <a:r>
+              <a:t>dashboard 403, sessions, task runner, subagents, cron,</a:t>
+            </a:r>
+          </a:p>
+          <a:p>
+            <a:pPr>
+              <a:spcBef>
+                <a:spcPts val="800"/>
+              </a:spcBef>
+              <a:defRPr sz="1800">
+                <a:solidFill>
+                  <a:srgbClr val="F1F5F9"/>
+                </a:solidFill>
+              </a:defRPr>
+            </a:pPr>
+            <a:r>
+              <a:t>config, snapshot, multi-instance, voice, artifact deploy</a:t>
+            </a:r>
+          </a:p>
+        </p:txBody>
+      </p:sp>
+    </p:spTree>
+  </p:cSld>
+  <p:clrMapOvr>
+    <a:masterClrMapping/>
+  </p:clrMapOvr>
+</p:sld>
+</file>
+
+<file path=ppt/slides/slide31.xml><?xml version="1.0" encoding="utf-8"?>
+<p:sld xmlns:a="http://schemas.openxmlformats.org/drawingml/2006/main" xmlns:p="http://schemas.openxmlformats.org/presentationml/2006/main" xmlns:r="http://schemas.openxmlformats.org/officeDocument/2006/relationships">
+  <p:cSld>
+    <p:bg>
+      <p:bgPr>
+        <a:solidFill>
+          <a:srgbClr val="1E293B"/>
+        </a:solidFill>
+        <a:effectLst/>
+      </p:bgPr>
+    </p:bg>
+    <p:spTree>
+      <p:nvGrpSpPr>
+        <p:cNvPr id="1" name=""/>
+        <p:cNvGrpSpPr/>
+        <p:nvPr/>
+      </p:nvGrpSpPr>
+      <p:grpSpPr/>
+      <p:sp>
+        <p:nvSpPr>
+          <p:cNvPr id="2" name="TextBox 1"/>
+          <p:cNvSpPr txBox="1"/>
+          <p:nvPr/>
+        </p:nvSpPr>
+        <p:spPr>
+          <a:xfrm>
+            <a:off x="914400" y="2743200"/>
+            <a:ext cx="7315200" cy="914400"/>
+          </a:xfrm>
+          <a:prstGeom prst="rect">
+            <a:avLst/>
+          </a:prstGeom>
+          <a:noFill/>
+        </p:spPr>
+        <p:txBody>
+          <a:bodyPr wrap="none">
+            <a:spAutoFit/>
+          </a:bodyPr>
+          <a:lstStyle/>
+          <a:p>
+            <a:pPr algn="ctr">
+              <a:defRPr sz="4400" b="1">
+                <a:solidFill>
+                  <a:srgbClr val="2563EB"/>
+                </a:solidFill>
+              </a:defRPr>
+            </a:pPr>
+            <a:r>
+              <a:t>Part 4: Use Cases</a:t>
+            </a:r>
+          </a:p>
+        </p:txBody>
+      </p:sp>
+      <p:sp>
+        <p:nvSpPr>
+          <p:cNvPr id="3" name="TextBox 2"/>
+          <p:cNvSpPr txBox="1"/>
+          <p:nvPr/>
+        </p:nvSpPr>
+        <p:spPr>
+          <a:xfrm>
+            <a:off x="914400" y="3840480"/>
+            <a:ext cx="7315200" cy="548640"/>
+          </a:xfrm>
+          <a:prstGeom prst="rect">
+            <a:avLst/>
+          </a:prstGeom>
+          <a:noFill/>
+        </p:spPr>
+        <p:txBody>
+          <a:bodyPr wrap="none">
+            <a:spAutoFit/>
+          </a:bodyPr>
+          <a:lstStyle/>
+          <a:p>
+            <a:pPr algn="ctr">
+              <a:defRPr sz="2000">
+                <a:solidFill>
+                  <a:srgbClr val="94A3B8"/>
+                </a:solidFill>
+              </a:defRPr>
+            </a:pPr>
+            <a:r>
+              <a:t>Enterprise integration examples</a:t>
+            </a:r>
+          </a:p>
+        </p:txBody>
+      </p:sp>
+    </p:spTree>
+  </p:cSld>
+  <p:clrMapOvr>
+    <a:masterClrMapping/>
+  </p:clrMapOvr>
+</p:sld>
+</file>
+
+<file path=ppt/slides/slide32.xml><?xml version="1.0" encoding="utf-8"?>
+<p:sld xmlns:a="http://schemas.openxmlformats.org/drawingml/2006/main" xmlns:p="http://schemas.openxmlformats.org/presentationml/2006/main" xmlns:r="http://schemas.openxmlformats.org/officeDocument/2006/relationships">
+  <p:cSld>
+    <p:bg>
+      <p:bgPr>
+        <a:solidFill>
+          <a:srgbClr val="0F172A"/>
+        </a:solidFill>
+        <a:effectLst/>
+      </p:bgPr>
+    </p:bg>
+    <p:spTree>
+      <p:nvGrpSpPr>
+        <p:cNvPr id="1" name=""/>
+        <p:cNvGrpSpPr/>
+        <p:nvPr/>
+      </p:nvGrpSpPr>
+      <p:grpSpPr/>
+      <p:sp>
+        <p:nvSpPr>
+          <p:cNvPr id="2" name="TextBox 1"/>
+          <p:cNvSpPr txBox="1"/>
+          <p:nvPr/>
+        </p:nvSpPr>
+        <p:spPr>
+          <a:xfrm>
+            <a:off x="457200" y="365760"/>
+            <a:ext cx="6858000" cy="548640"/>
+          </a:xfrm>
+          <a:prstGeom prst="rect">
+            <a:avLst/>
+          </a:prstGeom>
+          <a:noFill/>
+        </p:spPr>
+        <p:txBody>
+          <a:bodyPr wrap="none">
+            <a:spAutoFit/>
+          </a:bodyPr>
+          <a:lstStyle/>
+          <a:p>
+            <a:pPr>
+              <a:defRPr sz="3200" b="1">
+                <a:solidFill>
+                  <a:srgbClr val="2563EB"/>
+                </a:solidFill>
+              </a:defRPr>
+            </a:pPr>
+            <a:r>
+              <a:t>Example: 24/7 PR Monitoring</a:t>
+            </a:r>
+          </a:p>
+        </p:txBody>
+      </p:sp>
+      <p:sp>
+        <p:nvSpPr>
+          <p:cNvPr id="3" name="TextBox 2"/>
+          <p:cNvSpPr txBox="1"/>
+          <p:nvPr/>
+        </p:nvSpPr>
+        <p:spPr>
+          <a:xfrm>
+            <a:off x="7498079" y="411480"/>
+            <a:ext cx="1371600" cy="365760"/>
+          </a:xfrm>
+          <a:prstGeom prst="rect">
+            <a:avLst/>
+          </a:prstGeom>
+          <a:noFill/>
+        </p:spPr>
+        <p:txBody>
+          <a:bodyPr wrap="none">
+            <a:spAutoFit/>
+          </a:bodyPr>
+          <a:lstStyle/>
+          <a:p>
+            <a:pPr>
+              <a:defRPr sz="1100" b="1">
+                <a:solidFill>
+                  <a:srgbClr val="F59E0B"/>
+                </a:solidFill>
+              </a:defRPr>
+            </a:pPr>
+            <a:r>
+              <a:t>⚠ To Be Verified</a:t>
+            </a:r>
+          </a:p>
+        </p:txBody>
+      </p:sp>
+      <p:sp>
+        <p:nvSpPr>
+          <p:cNvPr id="4" name="TextBox 3"/>
+          <p:cNvSpPr txBox="1"/>
+          <p:nvPr/>
+        </p:nvSpPr>
+        <p:spPr>
+          <a:xfrm>
+            <a:off x="640080" y="1188720"/>
+            <a:ext cx="7863840" cy="5212080"/>
+          </a:xfrm>
+          <a:prstGeom prst="rect">
+            <a:avLst/>
+          </a:prstGeom>
+          <a:noFill/>
+        </p:spPr>
+        <p:txBody>
+          <a:bodyPr wrap="square">
+            <a:spAutoFit/>
+          </a:bodyPr>
+          <a:lstStyle/>
+          <a:p>
+            <a:pPr>
+              <a:spcBef>
+                <a:spcPts val="800"/>
+              </a:spcBef>
+              <a:defRPr sz="1800">
+                <a:solidFill>
+                  <a:srgbClr val="F1F5F9"/>
+                </a:solidFill>
+              </a:defRPr>
+            </a:pPr>
+            <a:r>
+              <a:t>Scenario: Track open PRs and alert on staleness</a:t>
+            </a:r>
+          </a:p>
+          <a:p>
+            <a:pPr>
+              <a:spcBef>
+                <a:spcPts val="800"/>
+              </a:spcBef>
+              <a:defRPr sz="1800">
+                <a:solidFill>
+                  <a:srgbClr val="F1F5F9"/>
+                </a:solidFill>
+              </a:defRPr>
+            </a:pPr>
+          </a:p>
+          <a:p>
+            <a:pPr>
+              <a:spcBef>
+                <a:spcPts val="800"/>
+              </a:spcBef>
+              <a:defRPr sz="1800">
+                <a:solidFill>
+                  <a:srgbClr val="F1F5F9"/>
+                </a:solidFill>
+              </a:defRPr>
+            </a:pPr>
+            <a:r>
+              <a:t>Implementation:</a:t>
+            </a:r>
+          </a:p>
+          <a:p>
+            <a:pPr>
+              <a:spcBef>
+                <a:spcPts val="800"/>
+              </a:spcBef>
+              <a:defRPr sz="1800">
+                <a:solidFill>
+                  <a:srgbClr val="F1F5F9"/>
+                </a:solidFill>
+              </a:defRPr>
+            </a:pPr>
+            <a:r>
+              <a:t>• Heartbeat watches open PRs</a:t>
+            </a:r>
+          </a:p>
+          <a:p>
+            <a:pPr>
+              <a:spcBef>
+                <a:spcPts val="800"/>
+              </a:spcBef>
+              <a:defRPr sz="1800">
+                <a:solidFill>
+                  <a:srgbClr val="F1F5F9"/>
+                </a:solidFill>
+              </a:defRPr>
+            </a:pPr>
+            <a:r>
+              <a:t>• Alerts when stale (&gt;4 hours no review)</a:t>
+            </a:r>
+          </a:p>
+          <a:p>
+            <a:pPr>
+              <a:spcBef>
+                <a:spcPts val="800"/>
+              </a:spcBef>
+              <a:defRPr sz="1800">
+                <a:solidFill>
+                  <a:srgbClr val="F1F5F9"/>
+                </a:solidFill>
+              </a:defRPr>
+            </a:pPr>
+            <a:r>
+              <a:t>• Auto-pings reviewers via Slack</a:t>
+            </a:r>
+          </a:p>
+          <a:p>
+            <a:pPr>
+              <a:spcBef>
+                <a:spcPts val="800"/>
+              </a:spcBef>
+              <a:defRPr sz="1800">
+                <a:solidFill>
+                  <a:srgbClr val="F1F5F9"/>
+                </a:solidFill>
+              </a:defRPr>
+            </a:pPr>
+          </a:p>
+          <a:p>
+            <a:pPr>
+              <a:spcBef>
+                <a:spcPts val="800"/>
+              </a:spcBef>
+              <a:defRPr sz="1800">
+                <a:solidFill>
+                  <a:srgbClr val="F1F5F9"/>
+                </a:solidFill>
+              </a:defRPr>
+            </a:pPr>
+            <a:r>
+              <a:t>Uses: Heartbeats + Slack integration</a:t>
+            </a:r>
+          </a:p>
+          <a:p>
+            <a:pPr>
+              <a:spcBef>
+                <a:spcPts val="800"/>
+              </a:spcBef>
+              <a:defRPr sz="1800">
+                <a:solidFill>
+                  <a:srgbClr val="F1F5F9"/>
+                </a:solidFill>
+              </a:defRPr>
+            </a:pPr>
+          </a:p>
+          <a:p>
+            <a:pPr>
+              <a:spcBef>
+                <a:spcPts val="800"/>
+              </a:spcBef>
+              <a:defRPr sz="1800">
+                <a:solidFill>
+                  <a:srgbClr val="F1F5F9"/>
+                </a:solidFill>
+              </a:defRPr>
+            </a:pPr>
+            <a:r>
+              <a:t>Note: Example scenario based on documented capabilities</a:t>
+            </a:r>
+          </a:p>
+        </p:txBody>
+      </p:sp>
+    </p:spTree>
+  </p:cSld>
+  <p:clrMapOvr>
+    <a:masterClrMapping/>
+  </p:clrMapOvr>
+</p:sld>
+</file>
+
+<file path=ppt/slides/slide33.xml><?xml version="1.0" encoding="utf-8"?>
+<p:sld xmlns:a="http://schemas.openxmlformats.org/drawingml/2006/main" xmlns:p="http://schemas.openxmlformats.org/presentationml/2006/main" xmlns:r="http://schemas.openxmlformats.org/officeDocument/2006/relationships">
+  <p:cSld>
+    <p:bg>
+      <p:bgPr>
+        <a:solidFill>
+          <a:srgbClr val="0F172A"/>
+        </a:solidFill>
+        <a:effectLst/>
+      </p:bgPr>
+    </p:bg>
+    <p:spTree>
+      <p:nvGrpSpPr>
+        <p:cNvPr id="1" name=""/>
+        <p:cNvGrpSpPr/>
+        <p:nvPr/>
+      </p:nvGrpSpPr>
+      <p:grpSpPr/>
+      <p:sp>
+        <p:nvSpPr>
+          <p:cNvPr id="2" name="TextBox 1"/>
+          <p:cNvSpPr txBox="1"/>
+          <p:nvPr/>
+        </p:nvSpPr>
+        <p:spPr>
+          <a:xfrm>
+            <a:off x="457200" y="365760"/>
+            <a:ext cx="6858000" cy="548640"/>
+          </a:xfrm>
+          <a:prstGeom prst="rect">
+            <a:avLst/>
+          </a:prstGeom>
+          <a:noFill/>
+        </p:spPr>
+        <p:txBody>
+          <a:bodyPr wrap="none">
+            <a:spAutoFit/>
+          </a:bodyPr>
+          <a:lstStyle/>
+          <a:p>
+            <a:pPr>
+              <a:defRPr sz="3200" b="1">
+                <a:solidFill>
+                  <a:srgbClr val="2563EB"/>
+                </a:solidFill>
+              </a:defRPr>
+            </a:pPr>
+            <a:r>
+              <a:t>Example: Nightly Security Audit</a:t>
+            </a:r>
+          </a:p>
+        </p:txBody>
+      </p:sp>
+      <p:sp>
+        <p:nvSpPr>
+          <p:cNvPr id="3" name="TextBox 2"/>
+          <p:cNvSpPr txBox="1"/>
+          <p:nvPr/>
+        </p:nvSpPr>
+        <p:spPr>
+          <a:xfrm>
+            <a:off x="7498079" y="411480"/>
+            <a:ext cx="1371600" cy="365760"/>
+          </a:xfrm>
+          <a:prstGeom prst="rect">
+            <a:avLst/>
+          </a:prstGeom>
+          <a:noFill/>
+        </p:spPr>
+        <p:txBody>
+          <a:bodyPr wrap="none">
+            <a:spAutoFit/>
+          </a:bodyPr>
+          <a:lstStyle/>
+          <a:p>
+            <a:pPr>
+              <a:defRPr sz="1100" b="1">
+                <a:solidFill>
+                  <a:srgbClr val="F59E0B"/>
+                </a:solidFill>
+              </a:defRPr>
+            </a:pPr>
+            <a:r>
+              <a:t>⚠ To Be Verified</a:t>
+            </a:r>
+          </a:p>
+        </p:txBody>
+      </p:sp>
+      <p:sp>
+        <p:nvSpPr>
+          <p:cNvPr id="4" name="TextBox 3"/>
+          <p:cNvSpPr txBox="1"/>
+          <p:nvPr/>
+        </p:nvSpPr>
+        <p:spPr>
+          <a:xfrm>
+            <a:off x="640080" y="1188720"/>
+            <a:ext cx="7863840" cy="5212080"/>
+          </a:xfrm>
+          <a:prstGeom prst="rect">
+            <a:avLst/>
+          </a:prstGeom>
+          <a:noFill/>
+        </p:spPr>
+        <p:txBody>
+          <a:bodyPr wrap="square">
+            <a:spAutoFit/>
+          </a:bodyPr>
+          <a:lstStyle/>
+          <a:p>
+            <a:pPr>
+              <a:spcBef>
+                <a:spcPts val="800"/>
+              </a:spcBef>
+              <a:defRPr sz="1800">
+                <a:solidFill>
+                  <a:srgbClr val="F1F5F9"/>
+                </a:solidFill>
+              </a:defRPr>
+            </a:pPr>
+            <a:r>
+              <a:t>Scenario: Automated security scanning</a:t>
+            </a:r>
+          </a:p>
+          <a:p>
+            <a:pPr>
+              <a:spcBef>
+                <a:spcPts val="800"/>
+              </a:spcBef>
+              <a:defRPr sz="1800">
+                <a:solidFill>
+                  <a:srgbClr val="F1F5F9"/>
+                </a:solidFill>
+              </a:defRPr>
+            </a:pPr>
+          </a:p>
+          <a:p>
+            <a:pPr>
+              <a:spcBef>
+                <a:spcPts val="800"/>
+              </a:spcBef>
+              <a:defRPr sz="1800">
+                <a:solidFill>
+                  <a:srgbClr val="F1F5F9"/>
+                </a:solidFill>
+              </a:defRPr>
+            </a:pPr>
+            <a:r>
+              <a:t>Implementation:</a:t>
+            </a:r>
+          </a:p>
+          <a:p>
+            <a:pPr>
+              <a:spcBef>
+                <a:spcPts val="800"/>
+              </a:spcBef>
+              <a:defRPr sz="1800">
+                <a:solidFill>
+                  <a:srgbClr val="F1F5F9"/>
+                </a:solidFill>
+              </a:defRPr>
+            </a:pPr>
+            <a:r>
+              <a:t>• Cron job at 2am</a:t>
+            </a:r>
+          </a:p>
+          <a:p>
+            <a:pPr>
+              <a:spcBef>
+                <a:spcPts val="800"/>
+              </a:spcBef>
+              <a:defRPr sz="1800">
+                <a:solidFill>
+                  <a:srgbClr val="F1F5F9"/>
+                </a:solidFill>
+              </a:defRPr>
+            </a:pPr>
+            <a:r>
+              <a:t>• Spawns subagents (one per repo)</a:t>
+            </a:r>
+          </a:p>
+          <a:p>
+            <a:pPr>
+              <a:spcBef>
+                <a:spcPts val="800"/>
+              </a:spcBef>
+              <a:defRPr sz="1800">
+                <a:solidFill>
+                  <a:srgbClr val="F1F5F9"/>
+                </a:solidFill>
+              </a:defRPr>
+            </a:pPr>
+            <a:r>
+              <a:t>• Scans for secrets, vulnerabilities, misconfigurations</a:t>
+            </a:r>
+          </a:p>
+          <a:p>
+            <a:pPr>
+              <a:spcBef>
+                <a:spcPts val="800"/>
+              </a:spcBef>
+              <a:defRPr sz="1800">
+                <a:solidFill>
+                  <a:srgbClr val="F1F5F9"/>
+                </a:solidFill>
+              </a:defRPr>
+            </a:pPr>
+            <a:r>
+              <a:t>• Aggregates findings into report</a:t>
+            </a:r>
+          </a:p>
+          <a:p>
+            <a:pPr>
+              <a:spcBef>
+                <a:spcPts val="800"/>
+              </a:spcBef>
+              <a:defRPr sz="1800">
+                <a:solidFill>
+                  <a:srgbClr val="F1F5F9"/>
+                </a:solidFill>
+              </a:defRPr>
+            </a:pPr>
+            <a:r>
+              <a:t>• Files HIGH/CRITICAL tickets</a:t>
+            </a:r>
+          </a:p>
+          <a:p>
+            <a:pPr>
+              <a:spcBef>
+                <a:spcPts val="800"/>
+              </a:spcBef>
+              <a:defRPr sz="1800">
+                <a:solidFill>
+                  <a:srgbClr val="F1F5F9"/>
+                </a:solidFill>
+              </a:defRPr>
+            </a:pPr>
+          </a:p>
+          <a:p>
+            <a:pPr>
+              <a:spcBef>
+                <a:spcPts val="800"/>
+              </a:spcBef>
+              <a:defRPr sz="1800">
+                <a:solidFill>
+                  <a:srgbClr val="F1F5F9"/>
+                </a:solidFill>
+              </a:defRPr>
+            </a:pPr>
+            <a:r>
+              <a:t>Uses: Cron + Subagents + Task automation</a:t>
+            </a:r>
+          </a:p>
+        </p:txBody>
+      </p:sp>
+    </p:spTree>
+  </p:cSld>
+  <p:clrMapOvr>
+    <a:masterClrMapping/>
+  </p:clrMapOvr>
+</p:sld>
+</file>
+
+<file path=ppt/slides/slide34.xml><?xml version="1.0" encoding="utf-8"?>
+<p:sld xmlns:a="http://schemas.openxmlformats.org/drawingml/2006/main" xmlns:p="http://schemas.openxmlformats.org/presentationml/2006/main" xmlns:r="http://schemas.openxmlformats.org/officeDocument/2006/relationships">
+  <p:cSld>
+    <p:bg>
+      <p:bgPr>
+        <a:solidFill>
+          <a:srgbClr val="0F172A"/>
+        </a:solidFill>
+        <a:effectLst/>
+      </p:bgPr>
+    </p:bg>
+    <p:spTree>
+      <p:nvGrpSpPr>
+        <p:cNvPr id="1" name=""/>
+        <p:cNvGrpSpPr/>
+        <p:nvPr/>
+      </p:nvGrpSpPr>
+      <p:grpSpPr/>
+      <p:sp>
+        <p:nvSpPr>
+          <p:cNvPr id="2" name="TextBox 1"/>
+          <p:cNvSpPr txBox="1"/>
+          <p:nvPr/>
+        </p:nvSpPr>
+        <p:spPr>
+          <a:xfrm>
+            <a:off x="457200" y="365760"/>
+            <a:ext cx="6858000" cy="548640"/>
+          </a:xfrm>
+          <a:prstGeom prst="rect">
+            <a:avLst/>
+          </a:prstGeom>
+          <a:noFill/>
+        </p:spPr>
+        <p:txBody>
+          <a:bodyPr wrap="none">
+            <a:spAutoFit/>
+          </a:bodyPr>
+          <a:lstStyle/>
+          <a:p>
+            <a:pPr>
+              <a:defRPr sz="3200" b="1">
+                <a:solidFill>
+                  <a:srgbClr val="2563EB"/>
+                </a:solidFill>
+              </a:defRPr>
+            </a:pPr>
+            <a:r>
+              <a:t>Example: Incident Response</a:t>
+            </a:r>
+          </a:p>
+        </p:txBody>
+      </p:sp>
+      <p:sp>
+        <p:nvSpPr>
+          <p:cNvPr id="3" name="TextBox 2"/>
+          <p:cNvSpPr txBox="1"/>
+          <p:nvPr/>
+        </p:nvSpPr>
+        <p:spPr>
+          <a:xfrm>
+            <a:off x="7498079" y="411480"/>
+            <a:ext cx="1371600" cy="365760"/>
+          </a:xfrm>
+          <a:prstGeom prst="rect">
+            <a:avLst/>
+          </a:prstGeom>
+          <a:noFill/>
+        </p:spPr>
+        <p:txBody>
+          <a:bodyPr wrap="none">
+            <a:spAutoFit/>
+          </a:bodyPr>
+          <a:lstStyle/>
+          <a:p>
+            <a:pPr>
+              <a:defRPr sz="1100" b="1">
+                <a:solidFill>
+                  <a:srgbClr val="F59E0B"/>
+                </a:solidFill>
+              </a:defRPr>
+            </a:pPr>
+            <a:r>
+              <a:t>⚠ To Be Verified</a:t>
+            </a:r>
+          </a:p>
+        </p:txBody>
+      </p:sp>
+      <p:sp>
+        <p:nvSpPr>
+          <p:cNvPr id="4" name="TextBox 3"/>
+          <p:cNvSpPr txBox="1"/>
+          <p:nvPr/>
+        </p:nvSpPr>
+        <p:spPr>
+          <a:xfrm>
+            <a:off x="640080" y="1188720"/>
+            <a:ext cx="7863840" cy="5212080"/>
+          </a:xfrm>
+          <a:prstGeom prst="rect">
+            <a:avLst/>
+          </a:prstGeom>
+          <a:noFill/>
+        </p:spPr>
+        <p:txBody>
+          <a:bodyPr wrap="square">
+            <a:spAutoFit/>
+          </a:bodyPr>
+          <a:lstStyle/>
+          <a:p>
+            <a:pPr>
+              <a:spcBef>
+                <a:spcPts val="800"/>
+              </a:spcBef>
+              <a:defRPr sz="1800">
+                <a:solidFill>
+                  <a:srgbClr val="F1F5F9"/>
+                </a:solidFill>
+              </a:defRPr>
+            </a:pPr>
+            <a:r>
+              <a:t>Scenario: Automated triage and RCA</a:t>
+            </a:r>
+          </a:p>
+          <a:p>
+            <a:pPr>
+              <a:spcBef>
+                <a:spcPts val="800"/>
+              </a:spcBef>
+              <a:defRPr sz="1800">
+                <a:solidFill>
+                  <a:srgbClr val="F1F5F9"/>
+                </a:solidFill>
+              </a:defRPr>
+            </a:pPr>
+          </a:p>
+          <a:p>
+            <a:pPr>
+              <a:spcBef>
+                <a:spcPts val="800"/>
+              </a:spcBef>
+              <a:defRPr sz="1800">
+                <a:solidFill>
+                  <a:srgbClr val="F1F5F9"/>
+                </a:solidFill>
+              </a:defRPr>
+            </a:pPr>
+            <a:r>
+              <a:t>Implementation:</a:t>
+            </a:r>
+          </a:p>
+          <a:p>
+            <a:pPr>
+              <a:spcBef>
+                <a:spcPts val="800"/>
+              </a:spcBef>
+              <a:defRPr sz="1800">
+                <a:solidFill>
+                  <a:srgbClr val="F1F5F9"/>
+                </a:solidFill>
+              </a:defRPr>
+            </a:pPr>
+            <a:r>
+              <a:t>• Webhook from PagerDuty</a:t>
+            </a:r>
+          </a:p>
+          <a:p>
+            <a:pPr>
+              <a:spcBef>
+                <a:spcPts val="800"/>
+              </a:spcBef>
+              <a:defRPr sz="1800">
+                <a:solidFill>
+                  <a:srgbClr val="F1F5F9"/>
+                </a:solidFill>
+              </a:defRPr>
+            </a:pPr>
+            <a:r>
+              <a:t>• Crew triages alert</a:t>
+            </a:r>
+          </a:p>
+          <a:p>
+            <a:pPr>
+              <a:spcBef>
+                <a:spcPts val="800"/>
+              </a:spcBef>
+              <a:defRPr sz="1800">
+                <a:solidFill>
+                  <a:srgbClr val="F1F5F9"/>
+                </a:solidFill>
+              </a:defRPr>
+            </a:pPr>
+            <a:r>
+              <a:t>• Checks logs, metrics, recent deploys</a:t>
+            </a:r>
+          </a:p>
+          <a:p>
+            <a:pPr>
+              <a:spcBef>
+                <a:spcPts val="800"/>
+              </a:spcBef>
+              <a:defRPr sz="1800">
+                <a:solidFill>
+                  <a:srgbClr val="F1F5F9"/>
+                </a:solidFill>
+              </a:defRPr>
+            </a:pPr>
+            <a:r>
+              <a:t>• Applies known fixes (from memory/lessons)</a:t>
+            </a:r>
+          </a:p>
+          <a:p>
+            <a:pPr>
+              <a:spcBef>
+                <a:spcPts val="800"/>
+              </a:spcBef>
+              <a:defRPr sz="1800">
+                <a:solidFill>
+                  <a:srgbClr val="F1F5F9"/>
+                </a:solidFill>
+              </a:defRPr>
+            </a:pPr>
+            <a:r>
+              <a:t>• Escalates if novel</a:t>
+            </a:r>
+          </a:p>
+          <a:p>
+            <a:pPr>
+              <a:spcBef>
+                <a:spcPts val="800"/>
+              </a:spcBef>
+              <a:defRPr sz="1800">
+                <a:solidFill>
+                  <a:srgbClr val="F1F5F9"/>
+                </a:solidFill>
+              </a:defRPr>
+            </a:pPr>
+            <a:r>
+              <a:t>• Posts RCA when resolved</a:t>
+            </a:r>
+          </a:p>
+          <a:p>
+            <a:pPr>
+              <a:spcBef>
+                <a:spcPts val="800"/>
+              </a:spcBef>
+              <a:defRPr sz="1800">
+                <a:solidFill>
+                  <a:srgbClr val="F1F5F9"/>
+                </a:solidFill>
+              </a:defRPr>
+            </a:pPr>
+          </a:p>
+          <a:p>
+            <a:pPr>
+              <a:spcBef>
+                <a:spcPts val="800"/>
+              </a:spcBef>
+              <a:defRPr sz="1800">
+                <a:solidFill>
+                  <a:srgbClr val="F1F5F9"/>
+                </a:solidFill>
+              </a:defRPr>
+            </a:pPr>
+            <a:r>
+              <a:t>Uses: Webhooks + Memory + Knowledge</a:t>
+            </a:r>
+          </a:p>
+        </p:txBody>
+      </p:sp>
+    </p:spTree>
+  </p:cSld>
+  <p:clrMapOvr>
+    <a:masterClrMapping/>
+  </p:clrMapOvr>
+</p:sld>
+</file>
+
+<file path=ppt/slides/slide35.xml><?xml version="1.0" encoding="utf-8"?>
+<p:sld xmlns:a="http://schemas.openxmlformats.org/drawingml/2006/main" xmlns:p="http://schemas.openxmlformats.org/presentationml/2006/main" xmlns:r="http://schemas.openxmlformats.org/officeDocument/2006/relationships">
+  <p:cSld>
+    <p:bg>
+      <p:bgPr>
+        <a:solidFill>
+          <a:srgbClr val="0F172A"/>
+        </a:solidFill>
+        <a:effectLst/>
+      </p:bgPr>
+    </p:bg>
+    <p:spTree>
+      <p:nvGrpSpPr>
+        <p:cNvPr id="1" name=""/>
+        <p:cNvGrpSpPr/>
+        <p:nvPr/>
+      </p:nvGrpSpPr>
+      <p:grpSpPr/>
+      <p:sp>
+        <p:nvSpPr>
+          <p:cNvPr id="2" name="TextBox 1"/>
+          <p:cNvSpPr txBox="1"/>
+          <p:nvPr/>
+        </p:nvSpPr>
+        <p:spPr>
+          <a:xfrm>
+            <a:off x="457200" y="365760"/>
+            <a:ext cx="6858000" cy="548640"/>
+          </a:xfrm>
+          <a:prstGeom prst="rect">
+            <a:avLst/>
+          </a:prstGeom>
+          <a:noFill/>
+        </p:spPr>
+        <p:txBody>
+          <a:bodyPr wrap="none">
+            <a:spAutoFit/>
+          </a:bodyPr>
+          <a:lstStyle/>
+          <a:p>
+            <a:pPr>
+              <a:defRPr sz="3200" b="1">
+                <a:solidFill>
+                  <a:srgbClr val="2563EB"/>
+                </a:solidFill>
+              </a:defRPr>
+            </a:pPr>
+            <a:r>
+              <a:t>CI/CD Integration (3 Modes)</a:t>
+            </a:r>
+          </a:p>
+        </p:txBody>
+      </p:sp>
+      <p:sp>
+        <p:nvSpPr>
+          <p:cNvPr id="3" name="TextBox 2"/>
+          <p:cNvSpPr txBox="1"/>
+          <p:nvPr/>
+        </p:nvSpPr>
+        <p:spPr>
+          <a:xfrm>
+            <a:off x="7498079" y="411480"/>
+            <a:ext cx="1371600" cy="365760"/>
+          </a:xfrm>
+          <a:prstGeom prst="rect">
+            <a:avLst/>
+          </a:prstGeom>
+          <a:noFill/>
+        </p:spPr>
+        <p:txBody>
+          <a:bodyPr wrap="none">
+            <a:spAutoFit/>
+          </a:bodyPr>
+          <a:lstStyle/>
+          <a:p>
+            <a:pPr>
+              <a:defRPr sz="1100" b="1">
+                <a:solidFill>
+                  <a:srgbClr val="10B981"/>
+                </a:solidFill>
+              </a:defRPr>
+            </a:pPr>
+            <a:r>
+              <a:t>✓ Verified</a:t>
+            </a:r>
+          </a:p>
+        </p:txBody>
+      </p:sp>
+      <p:sp>
+        <p:nvSpPr>
+          <p:cNvPr id="4" name="TextBox 3"/>
+          <p:cNvSpPr txBox="1"/>
+          <p:nvPr/>
+        </p:nvSpPr>
+        <p:spPr>
+          <a:xfrm>
+            <a:off x="640080" y="1188720"/>
+            <a:ext cx="7863840" cy="5212080"/>
+          </a:xfrm>
+          <a:prstGeom prst="rect">
+            <a:avLst/>
+          </a:prstGeom>
+          <a:noFill/>
+        </p:spPr>
+        <p:txBody>
+          <a:bodyPr wrap="square">
+            <a:spAutoFit/>
+          </a:bodyPr>
+          <a:lstStyle/>
+          <a:p>
+            <a:pPr>
+              <a:spcBef>
+                <a:spcPts val="800"/>
+              </a:spcBef>
+              <a:defRPr sz="1800">
+                <a:solidFill>
+                  <a:srgbClr val="F1F5F9"/>
+                </a:solidFill>
+              </a:defRPr>
+            </a:pPr>
+            <a:r>
+              <a:t>Mode 1: CLI Headless</a:t>
+            </a:r>
+          </a:p>
+          <a:p>
+            <a:pPr>
+              <a:spcBef>
+                <a:spcPts val="800"/>
+              </a:spcBef>
+              <a:defRPr sz="1800">
+                <a:solidFill>
+                  <a:srgbClr val="F1F5F9"/>
+                </a:solidFill>
+              </a:defRPr>
+            </a:pPr>
+            <a:r>
+              <a:t>• kiro-cli chat --no-interactive "&lt;prompt&gt;" in pipeline</a:t>
+            </a:r>
+          </a:p>
+          <a:p>
+            <a:pPr>
+              <a:spcBef>
+                <a:spcPts val="800"/>
+              </a:spcBef>
+              <a:defRPr sz="1800">
+                <a:solidFill>
+                  <a:srgbClr val="F1F5F9"/>
+                </a:solidFill>
+              </a:defRPr>
+            </a:pPr>
+            <a:r>
+              <a:t>• Engine version: --engine v3 (not --v3)</a:t>
+            </a:r>
+          </a:p>
+          <a:p>
+            <a:pPr>
+              <a:spcBef>
+                <a:spcPts val="800"/>
+              </a:spcBef>
+              <a:defRPr sz="1800">
+                <a:solidFill>
+                  <a:srgbClr val="F1F5F9"/>
+                </a:solidFill>
+              </a:defRPr>
+            </a:pPr>
+            <a:r>
+              <a:t>• Use case: Simple code generation</a:t>
+            </a:r>
+          </a:p>
+          <a:p>
+            <a:pPr>
+              <a:spcBef>
+                <a:spcPts val="800"/>
+              </a:spcBef>
+              <a:defRPr sz="1800">
+                <a:solidFill>
+                  <a:srgbClr val="F1F5F9"/>
+                </a:solidFill>
+              </a:defRPr>
+            </a:pPr>
+          </a:p>
+          <a:p>
+            <a:pPr>
+              <a:spcBef>
+                <a:spcPts val="800"/>
+              </a:spcBef>
+              <a:defRPr sz="1800">
+                <a:solidFill>
+                  <a:srgbClr val="F1F5F9"/>
+                </a:solidFill>
+              </a:defRPr>
+            </a:pPr>
+            <a:r>
+              <a:t>Mode 2: Crew Webhooks</a:t>
+            </a:r>
+          </a:p>
+          <a:p>
+            <a:pPr>
+              <a:spcBef>
+                <a:spcPts val="800"/>
+              </a:spcBef>
+              <a:defRPr sz="1800">
+                <a:solidFill>
+                  <a:srgbClr val="F1F5F9"/>
+                </a:solidFill>
+              </a:defRPr>
+            </a:pPr>
+            <a:r>
+              <a:t>• CI pipeline calls Crew on events</a:t>
+            </a:r>
+          </a:p>
+          <a:p>
+            <a:pPr>
+              <a:spcBef>
+                <a:spcPts val="800"/>
+              </a:spcBef>
+              <a:defRPr sz="1800">
+                <a:solidFill>
+                  <a:srgbClr val="F1F5F9"/>
+                </a:solidFill>
+              </a:defRPr>
+            </a:pPr>
+            <a:r>
+              <a:t>• Crew analyzes and reports via Slack/Dashboard</a:t>
+            </a:r>
+          </a:p>
+          <a:p>
+            <a:pPr>
+              <a:spcBef>
+                <a:spcPts val="800"/>
+              </a:spcBef>
+              <a:defRPr sz="1800">
+                <a:solidFill>
+                  <a:srgbClr val="F1F5F9"/>
+                </a:solidFill>
+              </a:defRPr>
+            </a:pPr>
+            <a:r>
+              <a:t>• Use case: Root cause analysis, monitoring</a:t>
+            </a:r>
+          </a:p>
+          <a:p>
+            <a:pPr>
+              <a:spcBef>
+                <a:spcPts val="800"/>
+              </a:spcBef>
+              <a:defRPr sz="1800">
+                <a:solidFill>
+                  <a:srgbClr val="F1F5F9"/>
+                </a:solidFill>
+              </a:defRPr>
+            </a:pPr>
+          </a:p>
+          <a:p>
+            <a:pPr>
+              <a:spcBef>
+                <a:spcPts val="800"/>
+              </a:spcBef>
+              <a:defRPr sz="1800">
+                <a:solidFill>
+                  <a:srgbClr val="F1F5F9"/>
+                </a:solidFill>
+              </a:defRPr>
+            </a:pPr>
+            <a:r>
+              <a:t>Mode 3: Crew Cron</a:t>
+            </a:r>
+          </a:p>
+          <a:p>
+            <a:pPr>
+              <a:spcBef>
+                <a:spcPts val="800"/>
+              </a:spcBef>
+              <a:defRPr sz="1800">
+                <a:solidFill>
+                  <a:srgbClr val="F1F5F9"/>
+                </a:solidFill>
+              </a:defRPr>
+            </a:pPr>
+            <a:r>
+              <a:t>• Periodic checks of CI/PR status</a:t>
+            </a:r>
+          </a:p>
+          <a:p>
+            <a:pPr>
+              <a:spcBef>
+                <a:spcPts val="800"/>
+              </a:spcBef>
+              <a:defRPr sz="1800">
+                <a:solidFill>
+                  <a:srgbClr val="F1F5F9"/>
+                </a:solidFill>
+              </a:defRPr>
+            </a:pPr>
+            <a:r>
+              <a:t>• Use case: Nightly audits, health checks</a:t>
+            </a:r>
+          </a:p>
+        </p:txBody>
+      </p:sp>
+    </p:spTree>
+  </p:cSld>
+  <p:clrMapOvr>
+    <a:masterClrMapping/>
+  </p:clrMapOvr>
+</p:sld>
+</file>
+
+<file path=ppt/slides/slide36.xml><?xml version="1.0" encoding="utf-8"?>
+<p:sld xmlns:a="http://schemas.openxmlformats.org/drawingml/2006/main" xmlns:p="http://schemas.openxmlformats.org/presentationml/2006/main" xmlns:r="http://schemas.openxmlformats.org/officeDocument/2006/relationships">
+  <p:cSld>
+    <p:bg>
+      <p:bgPr>
+        <a:solidFill>
+          <a:srgbClr val="1E293B"/>
+        </a:solidFill>
+        <a:effectLst/>
+      </p:bgPr>
+    </p:bg>
+    <p:spTree>
+      <p:nvGrpSpPr>
+        <p:cNvPr id="1" name=""/>
+        <p:cNvGrpSpPr/>
+        <p:nvPr/>
+      </p:nvGrpSpPr>
+      <p:grpSpPr/>
+      <p:sp>
+        <p:nvSpPr>
+          <p:cNvPr id="2" name="TextBox 1"/>
+          <p:cNvSpPr txBox="1"/>
+          <p:nvPr/>
+        </p:nvSpPr>
+        <p:spPr>
+          <a:xfrm>
+            <a:off x="914400" y="2743200"/>
+            <a:ext cx="7315200" cy="914400"/>
+          </a:xfrm>
+          <a:prstGeom prst="rect">
+            <a:avLst/>
+          </a:prstGeom>
+          <a:noFill/>
+        </p:spPr>
+        <p:txBody>
+          <a:bodyPr wrap="none">
+            <a:spAutoFit/>
+          </a:bodyPr>
+          <a:lstStyle/>
+          <a:p>
+            <a:pPr algn="ctr">
+              <a:defRPr sz="4400" b="1">
+                <a:solidFill>
+                  <a:srgbClr val="2563EB"/>
+                </a:solidFill>
+              </a:defRPr>
+            </a:pPr>
+            <a:r>
+              <a:t>Part 5: Getting Started</a:t>
+            </a:r>
+          </a:p>
+        </p:txBody>
+      </p:sp>
+    </p:spTree>
+  </p:cSld>
+  <p:clrMapOvr>
+    <a:masterClrMapping/>
+  </p:clrMapOvr>
+</p:sld>
+</file>
+
+<file path=ppt/slides/slide37.xml><?xml version="1.0" encoding="utf-8"?>
+<p:sld xmlns:a="http://schemas.openxmlformats.org/drawingml/2006/main" xmlns:p="http://schemas.openxmlformats.org/presentationml/2006/main" xmlns:r="http://schemas.openxmlformats.org/officeDocument/2006/relationships">
+  <p:cSld>
+    <p:bg>
+      <p:bgPr>
+        <a:solidFill>
+          <a:srgbClr val="0F172A"/>
+        </a:solidFill>
+        <a:effectLst/>
+      </p:bgPr>
+    </p:bg>
+    <p:spTree>
+      <p:nvGrpSpPr>
+        <p:cNvPr id="1" name=""/>
+        <p:cNvGrpSpPr/>
+        <p:nvPr/>
+      </p:nvGrpSpPr>
+      <p:grpSpPr/>
+      <p:sp>
+        <p:nvSpPr>
+          <p:cNvPr id="2" name="TextBox 1"/>
+          <p:cNvSpPr txBox="1"/>
+          <p:nvPr/>
+        </p:nvSpPr>
+        <p:spPr>
+          <a:xfrm>
+            <a:off x="457200" y="365760"/>
+            <a:ext cx="8229600" cy="548640"/>
+          </a:xfrm>
+          <a:prstGeom prst="rect">
+            <a:avLst/>
+          </a:prstGeom>
+          <a:noFill/>
+        </p:spPr>
+        <p:txBody>
+          <a:bodyPr wrap="none">
+            <a:spAutoFit/>
+          </a:bodyPr>
+          <a:lstStyle/>
+          <a:p>
+            <a:pPr>
+              <a:defRPr sz="3200" b="1">
+                <a:solidFill>
+                  <a:srgbClr val="2563EB"/>
+                </a:solidFill>
+              </a:defRPr>
+            </a:pPr>
+            <a:r>
+              <a:t>Installation</a:t>
+            </a:r>
+          </a:p>
+        </p:txBody>
+      </p:sp>
+      <p:sp>
+        <p:nvSpPr>
+          <p:cNvPr id="3" name="TextBox 2"/>
+          <p:cNvSpPr txBox="1"/>
+          <p:nvPr/>
+        </p:nvSpPr>
+        <p:spPr>
+          <a:xfrm>
+            <a:off x="457200" y="1188720"/>
+            <a:ext cx="4114800" cy="5212080"/>
+          </a:xfrm>
+          <a:prstGeom prst="rect">
+            <a:avLst/>
+          </a:prstGeom>
+          <a:noFill/>
+        </p:spPr>
+        <p:txBody>
+          <a:bodyPr wrap="square">
+            <a:spAutoFit/>
+          </a:bodyPr>
+          <a:lstStyle/>
+          <a:p>
+            <a:pPr>
+              <a:spcBef>
+                <a:spcPts val="600"/>
+              </a:spcBef>
+              <a:defRPr sz="1600">
+                <a:solidFill>
+                  <a:srgbClr val="F1F5F9"/>
+                </a:solidFill>
+              </a:defRPr>
+            </a:pPr>
+            <a:r>
+              <a:t>Option 1: Desktop App (Recommended)</a:t>
+            </a:r>
+          </a:p>
+          <a:p>
+            <a:pPr>
+              <a:spcBef>
+                <a:spcPts val="600"/>
+              </a:spcBef>
+              <a:defRPr sz="1600">
+                <a:solidFill>
+                  <a:srgbClr val="F1F5F9"/>
+                </a:solidFill>
+              </a:defRPr>
+            </a:pPr>
+            <a:r>
+              <a:t>1. Download (.dmg or .AppImage)</a:t>
+            </a:r>
+          </a:p>
+          <a:p>
+            <a:pPr>
+              <a:spcBef>
+                <a:spcPts val="600"/>
+              </a:spcBef>
+              <a:defRPr sz="1600">
+                <a:solidFill>
+                  <a:srgbClr val="F1F5F9"/>
+                </a:solidFill>
+              </a:defRPr>
+            </a:pPr>
+            <a:r>
+              <a:t>2. Launch (auto-starts Gateway)</a:t>
+            </a:r>
+          </a:p>
+          <a:p>
+            <a:pPr>
+              <a:spcBef>
+                <a:spcPts val="600"/>
+              </a:spcBef>
+              <a:defRPr sz="1600">
+                <a:solidFill>
+                  <a:srgbClr val="F1F5F9"/>
+                </a:solidFill>
+              </a:defRPr>
+            </a:pPr>
+            <a:r>
+              <a:t>3. Authenticate (device-code sign-in)</a:t>
+            </a:r>
+          </a:p>
+          <a:p>
+            <a:pPr>
+              <a:spcBef>
+                <a:spcPts val="600"/>
+              </a:spcBef>
+              <a:defRPr sz="1600">
+                <a:solidFill>
+                  <a:srgbClr val="F1F5F9"/>
+                </a:solidFill>
+              </a:defRPr>
+            </a:pPr>
+            <a:r>
+              <a:t>4. Start chatting</a:t>
+            </a:r>
+          </a:p>
+          <a:p>
+            <a:pPr>
+              <a:spcBef>
+                <a:spcPts val="600"/>
+              </a:spcBef>
+              <a:defRPr sz="1600">
+                <a:solidFill>
+                  <a:srgbClr val="F1F5F9"/>
+                </a:solidFill>
+              </a:defRPr>
+            </a:pPr>
+          </a:p>
+          <a:p>
+            <a:pPr>
+              <a:spcBef>
+                <a:spcPts val="600"/>
+              </a:spcBef>
+              <a:defRPr sz="1600">
+                <a:solidFill>
+                  <a:srgbClr val="F1F5F9"/>
+                </a:solidFill>
+              </a:defRPr>
+            </a:pPr>
+            <a:r>
+              <a:t>No AWS CLI needed</a:t>
+            </a:r>
+          </a:p>
+          <a:p>
+            <a:pPr>
+              <a:spcBef>
+                <a:spcPts val="600"/>
+              </a:spcBef>
+              <a:defRPr sz="1600">
+                <a:solidFill>
+                  <a:srgbClr val="F1F5F9"/>
+                </a:solidFill>
+              </a:defRPr>
+            </a:pPr>
+            <a:r>
+              <a:t>No Bedrock configuration needed</a:t>
+            </a:r>
+          </a:p>
+        </p:txBody>
+      </p:sp>
+      <p:sp>
+        <p:nvSpPr>
+          <p:cNvPr id="4" name="TextBox 3"/>
+          <p:cNvSpPr txBox="1"/>
+          <p:nvPr/>
+        </p:nvSpPr>
+        <p:spPr>
+          <a:xfrm>
+            <a:off x="4754880" y="1188720"/>
+            <a:ext cx="4114800" cy="5212080"/>
+          </a:xfrm>
+          <a:prstGeom prst="rect">
+            <a:avLst/>
+          </a:prstGeom>
+          <a:noFill/>
+        </p:spPr>
+        <p:txBody>
+          <a:bodyPr wrap="square">
+            <a:spAutoFit/>
+          </a:bodyPr>
+          <a:lstStyle/>
+          <a:p>
+            <a:pPr>
+              <a:spcBef>
+                <a:spcPts val="600"/>
+              </a:spcBef>
+              <a:defRPr sz="1600">
+                <a:solidFill>
+                  <a:srgbClr val="F1F5F9"/>
+                </a:solidFill>
+              </a:defRPr>
+            </a:pPr>
+            <a:r>
+              <a:t>Option 2: CLI Install</a:t>
+            </a:r>
+          </a:p>
+          <a:p>
+            <a:pPr>
+              <a:spcBef>
+                <a:spcPts val="600"/>
+              </a:spcBef>
+              <a:defRPr sz="1600">
+                <a:solidFill>
+                  <a:srgbClr val="F1F5F9"/>
+                </a:solidFill>
+              </a:defRPr>
+            </a:pPr>
+            <a:r>
+              <a:t>curl -fsSL https://download.crew.kiro.dev/cli.sh | sh</a:t>
+            </a:r>
+          </a:p>
+          <a:p>
+            <a:pPr>
+              <a:spcBef>
+                <a:spcPts val="600"/>
+              </a:spcBef>
+              <a:defRPr sz="1600">
+                <a:solidFill>
+                  <a:srgbClr val="F1F5F9"/>
+                </a:solidFill>
+              </a:defRPr>
+            </a:pPr>
+          </a:p>
+          <a:p>
+            <a:pPr>
+              <a:spcBef>
+                <a:spcPts val="600"/>
+              </a:spcBef>
+              <a:defRPr sz="1600">
+                <a:solidFill>
+                  <a:srgbClr val="F1F5F9"/>
+                </a:solidFill>
+              </a:defRPr>
+            </a:pPr>
+            <a:r>
+              <a:t>kirocrew setup</a:t>
+            </a:r>
+          </a:p>
+          <a:p>
+            <a:pPr>
+              <a:spcBef>
+                <a:spcPts val="600"/>
+              </a:spcBef>
+              <a:defRPr sz="1600">
+                <a:solidFill>
+                  <a:srgbClr val="F1F5F9"/>
+                </a:solidFill>
+              </a:defRPr>
+            </a:pPr>
+            <a:r>
+              <a:t>kirocrew doctor</a:t>
+            </a:r>
+          </a:p>
+          <a:p>
+            <a:pPr>
+              <a:spcBef>
+                <a:spcPts val="600"/>
+              </a:spcBef>
+              <a:defRPr sz="1600">
+                <a:solidFill>
+                  <a:srgbClr val="F1F5F9"/>
+                </a:solidFill>
+              </a:defRPr>
+            </a:pPr>
+            <a:r>
+              <a:t>kirocrew gateway</a:t>
+            </a:r>
+          </a:p>
+          <a:p>
+            <a:pPr>
+              <a:spcBef>
+                <a:spcPts val="600"/>
+              </a:spcBef>
+              <a:defRPr sz="1600">
+                <a:solidFill>
+                  <a:srgbClr val="F1F5F9"/>
+                </a:solidFill>
+              </a:defRPr>
+            </a:pPr>
+          </a:p>
+          <a:p>
+            <a:pPr>
+              <a:spcBef>
+                <a:spcPts val="600"/>
+              </a:spcBef>
+              <a:defRPr sz="1600">
+                <a:solidFill>
+                  <a:srgbClr val="F1F5F9"/>
+                </a:solidFill>
+              </a:defRPr>
+            </a:pPr>
+            <a:r>
+              <a:t>open http://localhost:5476</a:t>
+            </a:r>
+          </a:p>
+        </p:txBody>
+      </p:sp>
+    </p:spTree>
+  </p:cSld>
+  <p:clrMapOvr>
+    <a:masterClrMapping/>
+  </p:clrMapOvr>
+</p:sld>
+</file>
+
+<file path=ppt/slides/slide38.xml><?xml version="1.0" encoding="utf-8"?>
+<p:sld xmlns:a="http://schemas.openxmlformats.org/drawingml/2006/main" xmlns:p="http://schemas.openxmlformats.org/presentationml/2006/main" xmlns:r="http://schemas.openxmlformats.org/officeDocument/2006/relationships">
+  <p:cSld>
+    <p:bg>
+      <p:bgPr>
+        <a:solidFill>
+          <a:srgbClr val="0F172A"/>
+        </a:solidFill>
+        <a:effectLst/>
+      </p:bgPr>
+    </p:bg>
+    <p:spTree>
+      <p:nvGrpSpPr>
+        <p:cNvPr id="1" name=""/>
+        <p:cNvGrpSpPr/>
+        <p:nvPr/>
+      </p:nvGrpSpPr>
+      <p:grpSpPr/>
+      <p:sp>
+        <p:nvSpPr>
+          <p:cNvPr id="2" name="TextBox 1"/>
+          <p:cNvSpPr txBox="1"/>
+          <p:nvPr/>
+        </p:nvSpPr>
+        <p:spPr>
+          <a:xfrm>
+            <a:off x="457200" y="365760"/>
+            <a:ext cx="6858000" cy="548640"/>
+          </a:xfrm>
+          <a:prstGeom prst="rect">
+            <a:avLst/>
+          </a:prstGeom>
+          <a:noFill/>
+        </p:spPr>
+        <p:txBody>
+          <a:bodyPr wrap="none">
+            <a:spAutoFit/>
+          </a:bodyPr>
+          <a:lstStyle/>
+          <a:p>
+            <a:pPr>
+              <a:defRPr sz="3200" b="1">
+                <a:solidFill>
+                  <a:srgbClr val="2563EB"/>
+                </a:solidFill>
+              </a:defRPr>
+            </a:pPr>
+            <a:r>
+              <a:t>First Steps</a:t>
+            </a:r>
+          </a:p>
+        </p:txBody>
+      </p:sp>
+      <p:sp>
+        <p:nvSpPr>
+          <p:cNvPr id="3" name="TextBox 2"/>
+          <p:cNvSpPr txBox="1"/>
+          <p:nvPr/>
+        </p:nvSpPr>
+        <p:spPr>
+          <a:xfrm>
+            <a:off x="7498079" y="411480"/>
+            <a:ext cx="1371600" cy="365760"/>
+          </a:xfrm>
+          <a:prstGeom prst="rect">
+            <a:avLst/>
+          </a:prstGeom>
+          <a:noFill/>
+        </p:spPr>
+        <p:txBody>
+          <a:bodyPr wrap="none">
+            <a:spAutoFit/>
+          </a:bodyPr>
+          <a:lstStyle/>
+          <a:p>
+            <a:pPr>
+              <a:defRPr sz="1100" b="1">
+                <a:solidFill>
+                  <a:srgbClr val="10B981"/>
+                </a:solidFill>
+              </a:defRPr>
+            </a:pPr>
+            <a:r>
+              <a:t>✓ Verified</a:t>
+            </a:r>
+          </a:p>
+        </p:txBody>
+      </p:sp>
+      <p:sp>
+        <p:nvSpPr>
+          <p:cNvPr id="4" name="TextBox 3"/>
+          <p:cNvSpPr txBox="1"/>
+          <p:nvPr/>
+        </p:nvSpPr>
+        <p:spPr>
+          <a:xfrm>
+            <a:off x="640080" y="1188720"/>
+            <a:ext cx="7863840" cy="5212080"/>
+          </a:xfrm>
+          <a:prstGeom prst="rect">
+            <a:avLst/>
+          </a:prstGeom>
+          <a:noFill/>
+        </p:spPr>
+        <p:txBody>
+          <a:bodyPr wrap="square">
+            <a:spAutoFit/>
+          </a:bodyPr>
+          <a:lstStyle/>
+          <a:p>
+            <a:pPr>
+              <a:spcBef>
+                <a:spcPts val="800"/>
+              </a:spcBef>
+              <a:defRPr sz="1800">
+                <a:solidFill>
+                  <a:srgbClr val="F1F5F9"/>
+                </a:solidFill>
+              </a:defRPr>
+            </a:pPr>
+            <a:r>
+              <a:t>1. Chat - Type and ask anything in dashboard</a:t>
+            </a:r>
+          </a:p>
+          <a:p>
+            <a:pPr>
+              <a:spcBef>
+                <a:spcPts val="800"/>
+              </a:spcBef>
+              <a:defRPr sz="1800">
+                <a:solidFill>
+                  <a:srgbClr val="F1F5F9"/>
+                </a:solidFill>
+              </a:defRPr>
+            </a:pPr>
+          </a:p>
+          <a:p>
+            <a:pPr>
+              <a:spcBef>
+                <a:spcPts val="800"/>
+              </a:spcBef>
+              <a:defRPr sz="1800">
+                <a:solidFill>
+                  <a:srgbClr val="F1F5F9"/>
+                </a:solidFill>
+              </a:defRPr>
+            </a:pPr>
+            <a:r>
+              <a:t>2. Schedule a job - 'Every weekday at 9, summarize my open work'</a:t>
+            </a:r>
+          </a:p>
+          <a:p>
+            <a:pPr>
+              <a:spcBef>
+                <a:spcPts val="800"/>
+              </a:spcBef>
+              <a:defRPr sz="1800">
+                <a:solidFill>
+                  <a:srgbClr val="F1F5F9"/>
+                </a:solidFill>
+              </a:defRPr>
+            </a:pPr>
+          </a:p>
+          <a:p>
+            <a:pPr>
+              <a:spcBef>
+                <a:spcPts val="800"/>
+              </a:spcBef>
+              <a:defRPr sz="1800">
+                <a:solidFill>
+                  <a:srgbClr val="F1F5F9"/>
+                </a:solidFill>
+              </a:defRPr>
+            </a:pPr>
+            <a:r>
+              <a:t>3. Teach a preference - 'Always use pytest over unittest'</a:t>
+            </a:r>
+          </a:p>
+          <a:p>
+            <a:pPr>
+              <a:spcBef>
+                <a:spcPts val="800"/>
+              </a:spcBef>
+              <a:defRPr sz="1800">
+                <a:solidFill>
+                  <a:srgbClr val="F1F5F9"/>
+                </a:solidFill>
+              </a:defRPr>
+            </a:pPr>
+          </a:p>
+          <a:p>
+            <a:pPr>
+              <a:spcBef>
+                <a:spcPts val="800"/>
+              </a:spcBef>
+              <a:defRPr sz="1800">
+                <a:solidFill>
+                  <a:srgbClr val="F1F5F9"/>
+                </a:solidFill>
+              </a:defRPr>
+            </a:pPr>
+            <a:r>
+              <a:t>4. Run autonomous task - Projects panel → describe spec → Run</a:t>
+            </a:r>
+          </a:p>
+          <a:p>
+            <a:pPr>
+              <a:spcBef>
+                <a:spcPts val="800"/>
+              </a:spcBef>
+              <a:defRPr sz="1800">
+                <a:solidFill>
+                  <a:srgbClr val="F1F5F9"/>
+                </a:solidFill>
+              </a:defRPr>
+            </a:pPr>
+          </a:p>
+          <a:p>
+            <a:pPr>
+              <a:spcBef>
+                <a:spcPts val="800"/>
+              </a:spcBef>
+              <a:defRPr sz="1800">
+                <a:solidFill>
+                  <a:srgbClr val="F1F5F9"/>
+                </a:solidFill>
+              </a:defRPr>
+            </a:pPr>
+            <a:r>
+              <a:t>5. Delegate parallel work - 'Research these 3 options in parallel'</a:t>
+            </a:r>
+          </a:p>
+        </p:txBody>
+      </p:sp>
+    </p:spTree>
+  </p:cSld>
+  <p:clrMapOvr>
+    <a:masterClrMapping/>
+  </p:clrMapOvr>
+</p:sld>
+</file>
+
+<file path=ppt/slides/slide39.xml><?xml version="1.0" encoding="utf-8"?>
+<p:sld xmlns:a="http://schemas.openxmlformats.org/drawingml/2006/main" xmlns:p="http://schemas.openxmlformats.org/presentationml/2006/main" xmlns:r="http://schemas.openxmlformats.org/officeDocument/2006/relationships">
+  <p:cSld>
+    <p:bg>
+      <p:bgPr>
+        <a:solidFill>
+          <a:srgbClr val="0F172A"/>
+        </a:solidFill>
+        <a:effectLst/>
+      </p:bgPr>
+    </p:bg>
+    <p:spTree>
+      <p:nvGrpSpPr>
+        <p:cNvPr id="1" name=""/>
+        <p:cNvGrpSpPr/>
+        <p:nvPr/>
+      </p:nvGrpSpPr>
+      <p:grpSpPr/>
+      <p:sp>
+        <p:nvSpPr>
+          <p:cNvPr id="2" name="TextBox 1"/>
+          <p:cNvSpPr txBox="1"/>
+          <p:nvPr/>
+        </p:nvSpPr>
+        <p:spPr>
+          <a:xfrm>
+            <a:off x="457200" y="365760"/>
+            <a:ext cx="6858000" cy="548640"/>
+          </a:xfrm>
+          <a:prstGeom prst="rect">
+            <a:avLst/>
+          </a:prstGeom>
+          <a:noFill/>
+        </p:spPr>
+        <p:txBody>
+          <a:bodyPr wrap="none">
+            <a:spAutoFit/>
+          </a:bodyPr>
+          <a:lstStyle/>
+          <a:p>
+            <a:pPr>
+              <a:defRPr sz="3200" b="1">
+                <a:solidFill>
+                  <a:srgbClr val="2563EB"/>
+                </a:solidFill>
+              </a:defRPr>
+            </a:pPr>
+            <a:r>
+              <a:t>Resources</a:t>
+            </a:r>
+          </a:p>
+        </p:txBody>
+      </p:sp>
+      <p:sp>
+        <p:nvSpPr>
+          <p:cNvPr id="3" name="TextBox 2"/>
+          <p:cNvSpPr txBox="1"/>
+          <p:nvPr/>
+        </p:nvSpPr>
+        <p:spPr>
+          <a:xfrm>
+            <a:off x="7498079" y="411480"/>
+            <a:ext cx="1371600" cy="365760"/>
+          </a:xfrm>
+          <a:prstGeom prst="rect">
+            <a:avLst/>
+          </a:prstGeom>
+          <a:noFill/>
+        </p:spPr>
+        <p:txBody>
+          <a:bodyPr wrap="none">
+            <a:spAutoFit/>
+          </a:bodyPr>
+          <a:lstStyle/>
+          <a:p>
+            <a:pPr>
+              <a:defRPr sz="1100" b="1">
+                <a:solidFill>
+                  <a:srgbClr val="10B981"/>
+                </a:solidFill>
+              </a:defRPr>
+            </a:pPr>
+            <a:r>
+              <a:t>✓ Verified</a:t>
+            </a:r>
+          </a:p>
+        </p:txBody>
+      </p:sp>
+      <p:sp>
+        <p:nvSpPr>
+          <p:cNvPr id="4" name="TextBox 3"/>
+          <p:cNvSpPr txBox="1"/>
+          <p:nvPr/>
+        </p:nvSpPr>
+        <p:spPr>
+          <a:xfrm>
+            <a:off x="640080" y="1188720"/>
+            <a:ext cx="7863840" cy="5212080"/>
+          </a:xfrm>
+          <a:prstGeom prst="rect">
+            <a:avLst/>
+          </a:prstGeom>
+          <a:noFill/>
+        </p:spPr>
+        <p:txBody>
+          <a:bodyPr wrap="square">
+            <a:spAutoFit/>
+          </a:bodyPr>
+          <a:lstStyle/>
+          <a:p>
+            <a:pPr>
+              <a:spcBef>
+                <a:spcPts val="800"/>
+              </a:spcBef>
+              <a:defRPr sz="1800">
+                <a:solidFill>
+                  <a:srgbClr val="F1F5F9"/>
+                </a:solidFill>
+              </a:defRPr>
+            </a:pPr>
+            <a:r>
+              <a:t>Official Documentation:</a:t>
+            </a:r>
+          </a:p>
+          <a:p>
+            <a:pPr>
+              <a:spcBef>
+                <a:spcPts val="800"/>
+              </a:spcBef>
+              <a:defRPr sz="1800">
+                <a:solidFill>
+                  <a:srgbClr val="F1F5F9"/>
+                </a:solidFill>
+              </a:defRPr>
+            </a:pPr>
+            <a:r>
+              <a:t>• kiro.dev/docs/crew/ - Main docs</a:t>
+            </a:r>
+          </a:p>
+          <a:p>
+            <a:pPr>
+              <a:spcBef>
+                <a:spcPts val="800"/>
+              </a:spcBef>
+              <a:defRPr sz="1800">
+                <a:solidFill>
+                  <a:srgbClr val="F1F5F9"/>
+                </a:solidFill>
+              </a:defRPr>
+            </a:pPr>
+            <a:r>
+              <a:t>• kiro.dev/docs/crew/installation/ - Setup</a:t>
+            </a:r>
+          </a:p>
+          <a:p>
+            <a:pPr>
+              <a:spcBef>
+                <a:spcPts val="800"/>
+              </a:spcBef>
+              <a:defRPr sz="1800">
+                <a:solidFill>
+                  <a:srgbClr val="F1F5F9"/>
+                </a:solidFill>
+              </a:defRPr>
+            </a:pPr>
+            <a:r>
+              <a:t>• kiro.dev/docs/crew/features/ - Features</a:t>
+            </a:r>
+          </a:p>
+          <a:p>
+            <a:pPr>
+              <a:spcBef>
+                <a:spcPts val="800"/>
+              </a:spcBef>
+              <a:defRPr sz="1800">
+                <a:solidFill>
+                  <a:srgbClr val="F1F5F9"/>
+                </a:solidFill>
+              </a:defRPr>
+            </a:pPr>
+          </a:p>
+          <a:p>
+            <a:pPr>
+              <a:spcBef>
+                <a:spcPts val="800"/>
+              </a:spcBef>
+              <a:defRPr sz="1800">
+                <a:solidFill>
+                  <a:srgbClr val="F1F5F9"/>
+                </a:solidFill>
+              </a:defRPr>
+            </a:pPr>
+            <a:r>
+              <a:t>Specific Features:</a:t>
+            </a:r>
+          </a:p>
+          <a:p>
+            <a:pPr>
+              <a:spcBef>
+                <a:spcPts val="800"/>
+              </a:spcBef>
+              <a:defRPr sz="1800">
+                <a:solidFill>
+                  <a:srgbClr val="F1F5F9"/>
+                </a:solidFill>
+              </a:defRPr>
+            </a:pPr>
+            <a:r>
+              <a:t>• kiro.dev/docs/crew/features/memory/ - Memory</a:t>
+            </a:r>
+          </a:p>
+          <a:p>
+            <a:pPr>
+              <a:spcBef>
+                <a:spcPts val="800"/>
+              </a:spcBef>
+              <a:defRPr sz="1800">
+                <a:solidFill>
+                  <a:srgbClr val="F1F5F9"/>
+                </a:solidFill>
+              </a:defRPr>
+            </a:pPr>
+            <a:r>
+              <a:t>• kiro.dev/docs/crew/features/subagents/ - Subagents</a:t>
+            </a:r>
+          </a:p>
+          <a:p>
+            <a:pPr>
+              <a:spcBef>
+                <a:spcPts val="800"/>
+              </a:spcBef>
+              <a:defRPr sz="1800">
+                <a:solidFill>
+                  <a:srgbClr val="F1F5F9"/>
+                </a:solidFill>
+              </a:defRPr>
+            </a:pPr>
+            <a:r>
+              <a:t>• kiro.dev/docs/crew/features/cron/ - Scheduling</a:t>
+            </a:r>
+          </a:p>
+          <a:p>
+            <a:pPr>
+              <a:spcBef>
+                <a:spcPts val="800"/>
+              </a:spcBef>
+              <a:defRPr sz="1800">
+                <a:solidFill>
+                  <a:srgbClr val="F1F5F9"/>
+                </a:solidFill>
+              </a:defRPr>
+            </a:pPr>
+          </a:p>
+          <a:p>
+            <a:pPr>
+              <a:spcBef>
+                <a:spcPts val="800"/>
+              </a:spcBef>
+              <a:defRPr sz="1800">
+                <a:solidFill>
+                  <a:srgbClr val="F1F5F9"/>
+                </a:solidFill>
+              </a:defRPr>
+            </a:pPr>
+            <a:r>
+              <a:t>Pricing: kiro.dev/pricing/</a:t>
+            </a:r>
+          </a:p>
+        </p:txBody>
+      </p:sp>
+    </p:spTree>
+  </p:cSld>
+  <p:clrMapOvr>
+    <a:masterClrMapping/>
+  </p:clrMapOvr>
+</p:sld>
+</file>
+
 <file path=ppt/slides/slide4.xml><?xml version="1.0" encoding="utf-8"?>
 <p:sld xmlns:a="http://schemas.openxmlformats.org/drawingml/2006/main" xmlns:p="http://schemas.openxmlformats.org/presentationml/2006/main" xmlns:r="http://schemas.openxmlformats.org/officeDocument/2006/relationships">
   <p:cSld>
@@ -8354,6 +10696,137 @@
             </a:pPr>
             <a:r>
               <a:t>What is Kiro Crew?</a:t>
+            </a:r>
+          </a:p>
+        </p:txBody>
+      </p:sp>
+    </p:spTree>
+  </p:cSld>
+  <p:clrMapOvr>
+    <a:masterClrMapping/>
+  </p:clrMapOvr>
+</p:sld>
+</file>
+
+<file path=ppt/slides/slide40.xml><?xml version="1.0" encoding="utf-8"?>
+<p:sld xmlns:a="http://schemas.openxmlformats.org/drawingml/2006/main" xmlns:p="http://schemas.openxmlformats.org/presentationml/2006/main" xmlns:r="http://schemas.openxmlformats.org/officeDocument/2006/relationships">
+  <p:cSld>
+    <p:bg>
+      <p:bgPr>
+        <a:solidFill>
+          <a:srgbClr val="0F172A"/>
+        </a:solidFill>
+        <a:effectLst/>
+      </p:bgPr>
+    </p:bg>
+    <p:spTree>
+      <p:nvGrpSpPr>
+        <p:cNvPr id="1" name=""/>
+        <p:cNvGrpSpPr/>
+        <p:nvPr/>
+      </p:nvGrpSpPr>
+      <p:grpSpPr/>
+      <p:sp>
+        <p:nvSpPr>
+          <p:cNvPr id="2" name="TextBox 1"/>
+          <p:cNvSpPr txBox="1"/>
+          <p:nvPr/>
+        </p:nvSpPr>
+        <p:spPr>
+          <a:xfrm>
+            <a:off x="914400" y="2286000"/>
+            <a:ext cx="7315200" cy="914400"/>
+          </a:xfrm>
+          <a:prstGeom prst="rect">
+            <a:avLst/>
+          </a:prstGeom>
+          <a:noFill/>
+        </p:spPr>
+        <p:txBody>
+          <a:bodyPr wrap="none">
+            <a:spAutoFit/>
+          </a:bodyPr>
+          <a:lstStyle/>
+          <a:p>
+            <a:pPr algn="ctr">
+              <a:defRPr sz="5400" b="1">
+                <a:solidFill>
+                  <a:srgbClr val="F1F5F9"/>
+                </a:solidFill>
+              </a:defRPr>
+            </a:pPr>
+            <a:r>
+              <a:t>Questions?</a:t>
+            </a:r>
+          </a:p>
+        </p:txBody>
+      </p:sp>
+      <p:sp>
+        <p:nvSpPr>
+          <p:cNvPr id="3" name="TextBox 2"/>
+          <p:cNvSpPr txBox="1"/>
+          <p:nvPr/>
+        </p:nvSpPr>
+        <p:spPr>
+          <a:xfrm>
+            <a:off x="914400" y="3383280"/>
+            <a:ext cx="7315200" cy="731520"/>
+          </a:xfrm>
+          <a:prstGeom prst="rect">
+            <a:avLst/>
+          </a:prstGeom>
+          <a:noFill/>
+        </p:spPr>
+        <p:txBody>
+          <a:bodyPr wrap="none">
+            <a:spAutoFit/>
+          </a:bodyPr>
+          <a:lstStyle/>
+          <a:p>
+            <a:pPr algn="ctr">
+              <a:defRPr sz="2400">
+                <a:solidFill>
+                  <a:srgbClr val="94A3B8"/>
+                </a:solidFill>
+              </a:defRPr>
+            </a:pPr>
+            <a:r>
+              <a:t>Thank you for your attention</a:t>
+            </a:r>
+          </a:p>
+        </p:txBody>
+      </p:sp>
+      <p:sp>
+        <p:nvSpPr>
+          <p:cNvPr id="4" name="TextBox 3"/>
+          <p:cNvSpPr txBox="1"/>
+          <p:nvPr/>
+        </p:nvSpPr>
+        <p:spPr>
+          <a:xfrm>
+            <a:off x="914400" y="5943600"/>
+            <a:ext cx="7315200" cy="457200"/>
+          </a:xfrm>
+          <a:prstGeom prst="rect">
+            <a:avLst/>
+          </a:prstGeom>
+          <a:noFill/>
+        </p:spPr>
+        <p:txBody>
+          <a:bodyPr wrap="none">
+            <a:spAutoFit/>
+          </a:bodyPr>
+          <a:lstStyle/>
+          <a:p>
+            <a:pPr algn="ctr">
+              <a:defRPr sz="1400">
+                <a:solidFill>
+                  <a:srgbClr val="06B6D4"/>
+                </a:solidFill>
+              </a:defRPr>
+            </a:pPr>
+            <a:r>
+              <a:t>✓ All facts sourced from official docs | Verified 2026-08-31</a:t>
             </a:r>
           </a:p>
         </p:txBody>

</xml_diff>